<commit_message>
bench: run 2026-10-17T1611Z-426bfe9 deck rebuilt and visually reviewed; receipt bound to deck and renders
</commit_message>
<xml_diff>
--- a/bench/runs/2026-10-17T1611Z-426bfe9/results/deck.pptx
+++ b/bench/runs/2026-10-17T1611Z-426bfe9/results/deck.pptx
@@ -3513,14 +3513,39 @@
       </p:sp>
       <p:sp>
         <p:nvSpPr>
-          <p:cNvPr id="8" name="slide-title:content"/>
+          <p:cNvPr id="8" name="Shape 6"/>
+          <p:cNvSpPr/>
+          <p:nvPr/>
+        </p:nvSpPr>
+        <p:spPr>
+          <a:xfrm>
+            <a:off x="457200" y="192024"/>
+            <a:ext cx="50292" cy="903224"/>
+          </a:xfrm>
+          <a:prstGeom prst="rect">
+            <a:avLst/>
+          </a:prstGeom>
+          <a:solidFill>
+            <a:srgbClr val="C9302C"/>
+          </a:solidFill>
+          <a:ln w="12700">
+            <a:solidFill>
+              <a:srgbClr val="C9302C"/>
+            </a:solidFill>
+            <a:prstDash val="solid"/>
+          </a:ln>
+        </p:spPr>
+      </p:sp>
+      <p:sp>
+        <p:nvSpPr>
+          <p:cNvPr id="9" name="slide-title:content"/>
           <p:cNvSpPr txBox="1"/>
           <p:nvPr/>
         </p:nvSpPr>
         <p:spPr>
           <a:xfrm>
-            <a:off x="457200" y="173736"/>
-            <a:ext cx="8229600" cy="983488"/>
+            <a:off x="640080" y="173736"/>
+            <a:ext cx="8046720" cy="528320"/>
           </a:xfrm>
           <a:prstGeom prst="rect">
             <a:avLst/>
@@ -3544,39 +3569,86 @@
                 <a:ea typeface="Helvetica Neue" pitchFamily="34" charset="-122"/>
                 <a:cs typeface="Helvetica Neue" pitchFamily="34" charset="-120"/>
               </a:rPr>
-              <a:t>One perturbed prediction, two views (CDK2,</a:t>
+              <a:t>One perturbed prediction, two views</a:t>
             </a:r>
             <a:endParaRPr lang="en-US" sz="2800" dirty="0"/>
           </a:p>
+        </p:txBody>
+      </p:sp>
+      <p:sp>
+        <p:nvSpPr>
+          <p:cNvPr id="10" name="support:slide-subtitle"/>
+          <p:cNvSpPr txBox="1"/>
+          <p:nvPr/>
+        </p:nvSpPr>
+        <p:spPr>
+          <a:xfrm>
+            <a:off x="640080" y="738632"/>
+            <a:ext cx="8046720" cy="292608"/>
+          </a:xfrm>
+          <a:prstGeom prst="rect">
+            <a:avLst/>
+          </a:prstGeom>
+          <a:noFill/>
+          <a:ln/>
+        </p:spPr>
+        <p:txBody>
+          <a:bodyPr wrap="square" lIns="0" tIns="0" rIns="0" bIns="0" rtlCol="0" anchor="t"/>
+          <a:lstStyle/>
           <a:p>
             <a:pPr algn="l" indent="0" marL="0">
               <a:buNone/>
             </a:pPr>
             <a:r>
-              <a:rPr lang="en-US" sz="2800" b="1" dirty="0">
+              <a:rPr lang="en-US" sz="1300" dirty="0">
                 <a:solidFill>
-                  <a:srgbClr val="1B2838"/>
+                  <a:srgbClr val="4B5563"/>
                 </a:solidFill>
                 <a:latin typeface="Helvetica Neue" pitchFamily="34" charset="0"/>
                 <a:ea typeface="Helvetica Neue" pitchFamily="34" charset="-122"/>
                 <a:cs typeface="Helvetica Neue" pitchFamily="34" charset="-120"/>
               </a:rPr>
-              <a:t>Boltz-2)</a:t>
+              <a:t>CDK2, Boltz-2, 13 contacts to glycine</a:t>
             </a:r>
-            <a:endParaRPr lang="en-US" sz="2800" dirty="0"/>
+            <a:endParaRPr lang="en-US" sz="1300" dirty="0"/>
           </a:p>
         </p:txBody>
       </p:sp>
       <p:sp>
         <p:nvSpPr>
-          <p:cNvPr id="9" name="Shape 7"/>
+          <p:cNvPr id="11" name="Shape 9"/>
           <p:cNvSpPr/>
           <p:nvPr/>
         </p:nvSpPr>
         <p:spPr>
           <a:xfrm>
-            <a:off x="457200" y="1201115"/>
-            <a:ext cx="2377440" cy="31090"/>
+            <a:off x="457200" y="1086104"/>
+            <a:ext cx="8229600" cy="12802"/>
+          </a:xfrm>
+          <a:prstGeom prst="rect">
+            <a:avLst/>
+          </a:prstGeom>
+          <a:solidFill>
+            <a:srgbClr val="D1D5DB"/>
+          </a:solidFill>
+          <a:ln w="12700">
+            <a:solidFill>
+              <a:srgbClr val="D1D5DB"/>
+            </a:solidFill>
+            <a:prstDash val="solid"/>
+          </a:ln>
+        </p:spPr>
+      </p:sp>
+      <p:sp>
+        <p:nvSpPr>
+          <p:cNvPr id="12" name="Shape 10"/>
+          <p:cNvSpPr/>
+          <p:nvPr/>
+        </p:nvSpPr>
+        <p:spPr>
+          <a:xfrm>
+            <a:off x="457200" y="1117194"/>
+            <a:ext cx="1097280" cy="23774"/>
           </a:xfrm>
           <a:prstGeom prst="rect">
             <a:avLst/>
@@ -3594,39 +3666,14 @@
       </p:sp>
       <p:sp>
         <p:nvSpPr>
-          <p:cNvPr id="10" name="Shape 8"/>
+          <p:cNvPr id="13" name="role-contract-slot:comparison:option-0"/>
           <p:cNvSpPr/>
           <p:nvPr/>
         </p:nvSpPr>
         <p:spPr>
           <a:xfrm>
-            <a:off x="2944368" y="1212088"/>
-            <a:ext cx="5742432" cy="12802"/>
-          </a:xfrm>
-          <a:prstGeom prst="rect">
-            <a:avLst/>
-          </a:prstGeom>
-          <a:solidFill>
-            <a:srgbClr val="D1D5DB"/>
-          </a:solidFill>
-          <a:ln w="12700">
-            <a:solidFill>
-              <a:srgbClr val="D1D5DB"/>
-            </a:solidFill>
-            <a:prstDash val="solid"/>
-          </a:ln>
-        </p:spPr>
-      </p:sp>
-      <p:sp>
-        <p:nvSpPr>
-          <p:cNvPr id="11" name="role-contract-slot:comparison:option-0"/>
-          <p:cNvSpPr/>
-          <p:nvPr/>
-        </p:nvSpPr>
-        <p:spPr>
-          <a:xfrm>
-            <a:off x="457200" y="1541272"/>
-            <a:ext cx="3950208" cy="3071876"/>
+            <a:off x="457200" y="1415288"/>
+            <a:ext cx="3950208" cy="3197860"/>
           </a:xfrm>
           <a:prstGeom prst="rect">
             <a:avLst/>
@@ -3644,13 +3691,13 @@
       </p:sp>
       <p:sp>
         <p:nvSpPr>
-          <p:cNvPr id="12" name="comparison:0:title"/>
+          <p:cNvPr id="14" name="comparison:0:title"/>
           <p:cNvSpPr txBox="1"/>
           <p:nvPr/>
         </p:nvSpPr>
         <p:spPr>
           <a:xfrm>
-            <a:off x="603504" y="1687576"/>
+            <a:off x="603504" y="1561592"/>
             <a:ext cx="3657600" cy="397256"/>
           </a:xfrm>
           <a:prstGeom prst="rect">
@@ -3683,13 +3730,13 @@
       </p:sp>
       <p:sp>
         <p:nvSpPr>
-          <p:cNvPr id="13" name="comparison:0:body"/>
+          <p:cNvPr id="15" name="comparison:0:body"/>
           <p:cNvSpPr txBox="1"/>
           <p:nvPr/>
         </p:nvSpPr>
         <p:spPr>
           <a:xfrm>
-            <a:off x="603504" y="2176272"/>
+            <a:off x="603504" y="2050288"/>
             <a:ext cx="3657600" cy="1697736"/>
           </a:xfrm>
           <a:prstGeom prst="rect">
@@ -3807,14 +3854,14 @@
       </p:sp>
       <p:sp>
         <p:nvSpPr>
-          <p:cNvPr id="14" name="role-contract-slot:comparison:option-1"/>
+          <p:cNvPr id="16" name="role-contract-slot:comparison:option-1"/>
           <p:cNvSpPr/>
           <p:nvPr/>
         </p:nvSpPr>
         <p:spPr>
           <a:xfrm>
-            <a:off x="4736592" y="1541272"/>
-            <a:ext cx="3950208" cy="3071876"/>
+            <a:off x="4736592" y="1415288"/>
+            <a:ext cx="3950208" cy="3197860"/>
           </a:xfrm>
           <a:prstGeom prst="rect">
             <a:avLst/>
@@ -3832,13 +3879,13 @@
       </p:sp>
       <p:sp>
         <p:nvSpPr>
-          <p:cNvPr id="15" name="comparison:1:title"/>
+          <p:cNvPr id="17" name="comparison:1:title"/>
           <p:cNvSpPr txBox="1"/>
           <p:nvPr/>
         </p:nvSpPr>
         <p:spPr>
           <a:xfrm>
-            <a:off x="4882896" y="1687576"/>
+            <a:off x="4882896" y="1561592"/>
             <a:ext cx="3657600" cy="397256"/>
           </a:xfrm>
           <a:prstGeom prst="rect">
@@ -3871,13 +3918,13 @@
       </p:sp>
       <p:sp>
         <p:nvSpPr>
-          <p:cNvPr id="16" name="comparison:1:body"/>
+          <p:cNvPr id="18" name="comparison:1:body"/>
           <p:cNvSpPr txBox="1"/>
           <p:nvPr/>
         </p:nvSpPr>
         <p:spPr>
           <a:xfrm>
-            <a:off x="4882896" y="2176272"/>
+            <a:off x="4882896" y="2050288"/>
             <a:ext cx="3657600" cy="1697736"/>
           </a:xfrm>
           <a:prstGeom prst="rect">
@@ -3995,7 +4042,7 @@
       </p:sp>
       <p:sp>
         <p:nvSpPr>
-          <p:cNvPr id="17" name="Shape 15"/>
+          <p:cNvPr id="19" name="Shape 17"/>
           <p:cNvSpPr/>
           <p:nvPr/>
         </p:nvSpPr>
@@ -4020,7 +4067,7 @@
       </p:sp>
       <p:sp>
         <p:nvSpPr>
-          <p:cNvPr id="18" name="metadata:footer-sources"/>
+          <p:cNvPr id="20" name="metadata:footer-sources"/>
           <p:cNvSpPr txBox="1"/>
           <p:nvPr/>
         </p:nvSpPr>
@@ -4061,7 +4108,7 @@
       </p:sp>
       <p:sp>
         <p:nvSpPr>
-          <p:cNvPr id="19" name="metadata:footer-page-number"/>
+          <p:cNvPr id="21" name="metadata:footer-page-number"/>
           <p:cNvSpPr txBox="1"/>
           <p:nvPr/>
         </p:nvSpPr>
@@ -4307,7 +4354,7 @@
         <p:spPr>
           <a:xfrm>
             <a:off x="457200" y="173736"/>
-            <a:ext cx="8229600" cy="983488"/>
+            <a:ext cx="8229600" cy="528320"/>
           </a:xfrm>
           <a:prstGeom prst="rect">
             <a:avLst/>
@@ -4331,38 +4378,60 @@
                 <a:ea typeface="Helvetica Neue" pitchFamily="34" charset="-122"/>
                 <a:cs typeface="Helvetica Neue" pitchFamily="34" charset="-120"/>
               </a:rPr>
-              <a:t>The ligand stays in a pocket whose contacts</a:t>
+              <a:t>Medoid poses, wild type and perturbed</a:t>
             </a:r>
             <a:endParaRPr lang="en-US" sz="2800" dirty="0"/>
           </a:p>
+        </p:txBody>
+      </p:sp>
+      <p:sp>
+        <p:nvSpPr>
+          <p:cNvPr id="9" name="support:slide-subtitle"/>
+          <p:cNvSpPr txBox="1"/>
+          <p:nvPr/>
+        </p:nvSpPr>
+        <p:spPr>
+          <a:xfrm>
+            <a:off x="457200" y="738632"/>
+            <a:ext cx="8229600" cy="292608"/>
+          </a:xfrm>
+          <a:prstGeom prst="rect">
+            <a:avLst/>
+          </a:prstGeom>
+          <a:noFill/>
+          <a:ln/>
+        </p:spPr>
+        <p:txBody>
+          <a:bodyPr wrap="square" lIns="0" tIns="0" rIns="0" bIns="0" rtlCol="0" anchor="t"/>
+          <a:lstStyle/>
           <a:p>
             <a:pPr algn="l" indent="0" marL="0">
               <a:buNone/>
             </a:pPr>
             <a:r>
-              <a:rPr lang="en-US" sz="2800" b="1" dirty="0">
+              <a:rPr lang="en-US" sz="1300" dirty="0">
                 <a:solidFill>
-                  <a:srgbClr val="1B2838"/>
+                  <a:srgbClr val="4B5563"/>
                 </a:solidFill>
                 <a:latin typeface="Helvetica Neue" pitchFamily="34" charset="0"/>
                 <a:ea typeface="Helvetica Neue" pitchFamily="34" charset="-122"/>
                 <a:cs typeface="Helvetica Neue" pitchFamily="34" charset="-120"/>
               </a:rPr>
-              <a:t>are gone</a:t>
+              <a:t>CDK2, Boltz-2</a:t>
             </a:r>
-            <a:endParaRPr lang="en-US" sz="2800" dirty="0"/>
+            <a:endParaRPr lang="en-US" sz="1300" dirty="0"/>
           </a:p>
         </p:txBody>
       </p:sp>
       <p:sp>
         <p:nvSpPr>
-          <p:cNvPr id="9" name="support:scientific:A:title"/>
+          <p:cNvPr id="10" name="support:scientific:A:title"/>
           <p:cNvSpPr txBox="1"/>
           <p:nvPr/>
         </p:nvSpPr>
         <p:spPr>
           <a:xfrm>
-            <a:off x="530352" y="1568704"/>
+            <a:off x="530352" y="1442720"/>
             <a:ext cx="3831336" cy="348488"/>
           </a:xfrm>
           <a:prstGeom prst="rect">
@@ -4395,7 +4464,7 @@
       </p:sp>
       <p:pic>
         <p:nvPicPr>
-          <p:cNvPr id="10" name="scientific:A:image" descr="PyMOL renders of the medoid poses, same view per panel.">    </p:cNvPr>
+          <p:cNvPr id="11" name="scientific:A:image" descr="Each panel oriented on its ligand; grey: residues ≤ 5 Å.">    </p:cNvPr>
           <p:cNvPicPr>
             <a:picLocks noChangeAspect="1"/>
           </p:cNvPicPr>
@@ -4409,8 +4478,8 @@
         </p:blipFill>
         <p:spPr>
           <a:xfrm>
-            <a:off x="1328081" y="1944624"/>
-            <a:ext cx="2235877" cy="1676908"/>
+            <a:off x="1244092" y="1818640"/>
+            <a:ext cx="2403856" cy="1802892"/>
           </a:xfrm>
           <a:prstGeom prst="rect">
             <a:avLst/>
@@ -4419,7 +4488,7 @@
       </p:pic>
       <p:sp>
         <p:nvSpPr>
-          <p:cNvPr id="11" name="metadata:scientific:A:caption"/>
+          <p:cNvPr id="12" name="metadata:scientific:A:caption"/>
           <p:cNvSpPr txBox="1"/>
           <p:nvPr/>
         </p:nvSpPr>
@@ -4458,13 +4527,13 @@
       </p:sp>
       <p:sp>
         <p:nvSpPr>
-          <p:cNvPr id="12" name="support:scientific:B:title"/>
+          <p:cNvPr id="13" name="support:scientific:B:title"/>
           <p:cNvSpPr txBox="1"/>
           <p:nvPr/>
         </p:nvSpPr>
         <p:spPr>
           <a:xfrm>
-            <a:off x="4782312" y="1568704"/>
+            <a:off x="4782312" y="1442720"/>
             <a:ext cx="3831336" cy="348488"/>
           </a:xfrm>
           <a:prstGeom prst="rect">
@@ -4497,7 +4566,7 @@
       </p:sp>
       <p:pic>
         <p:nvPicPr>
-          <p:cNvPr id="13" name="scientific:B:image" descr="PyMOL renders of the medoid poses, same view per panel.">    </p:cNvPr>
+          <p:cNvPr id="14" name="scientific:B:image" descr="Each panel oriented on its ligand; grey: residues ≤ 5 Å.">    </p:cNvPr>
           <p:cNvPicPr>
             <a:picLocks noChangeAspect="1"/>
           </p:cNvPicPr>
@@ -4511,8 +4580,8 @@
         </p:blipFill>
         <p:spPr>
           <a:xfrm>
-            <a:off x="5580041" y="1944624"/>
-            <a:ext cx="2235877" cy="1676908"/>
+            <a:off x="5496052" y="1818640"/>
+            <a:ext cx="2403856" cy="1802892"/>
           </a:xfrm>
           <a:prstGeom prst="rect">
             <a:avLst/>
@@ -4521,7 +4590,7 @@
       </p:pic>
       <p:sp>
         <p:nvSpPr>
-          <p:cNvPr id="14" name="metadata:scientific:B:caption"/>
+          <p:cNvPr id="15" name="metadata:scientific:B:caption"/>
           <p:cNvSpPr txBox="1"/>
           <p:nvPr/>
         </p:nvSpPr>
@@ -4560,7 +4629,7 @@
       </p:sp>
       <p:sp>
         <p:nvSpPr>
-          <p:cNvPr id="15" name="scientific:complete-readout"/>
+          <p:cNvPr id="16" name="scientific:complete-readout"/>
           <p:cNvSpPr txBox="1"/>
           <p:nvPr/>
         </p:nvSpPr>
@@ -4591,7 +4660,7 @@
                 <a:ea typeface="Helvetica Neue" pitchFamily="34" charset="-122"/>
                 <a:cs typeface="Helvetica Neue" pitchFamily="34" charset="-120"/>
               </a:rPr>
-              <a:t>PyMOL renders of the medoid poses, same view per panel.</a:t>
+              <a:t>Each panel oriented on its ligand; grey: residues ≤ 5 Å.</a:t>
             </a:r>
             <a:endParaRPr lang="en-US" sz="1600" dirty="0"/>
           </a:p>
@@ -4599,7 +4668,7 @@
       </p:sp>
       <p:sp>
         <p:nvSpPr>
-          <p:cNvPr id="16" name="Shape 12"/>
+          <p:cNvPr id="17" name="Shape 13"/>
           <p:cNvSpPr/>
           <p:nvPr/>
         </p:nvSpPr>
@@ -4624,7 +4693,7 @@
       </p:sp>
       <p:sp>
         <p:nvSpPr>
-          <p:cNvPr id="17" name="metadata:footer-sources"/>
+          <p:cNvPr id="18" name="metadata:footer-sources"/>
           <p:cNvSpPr txBox="1"/>
           <p:nvPr/>
         </p:nvSpPr>
@@ -4665,7 +4734,7 @@
       </p:sp>
       <p:sp>
         <p:nvSpPr>
-          <p:cNvPr id="18" name="metadata:footer-page-number"/>
+          <p:cNvPr id="19" name="metadata:footer-page-number"/>
           <p:cNvSpPr txBox="1"/>
           <p:nvPr/>
         </p:nvSpPr>
@@ -4904,14 +4973,39 @@
       </p:sp>
       <p:sp>
         <p:nvSpPr>
-          <p:cNvPr id="8" name="slide-title:content"/>
+          <p:cNvPr id="8" name="Shape 6"/>
+          <p:cNvSpPr/>
+          <p:nvPr/>
+        </p:nvSpPr>
+        <p:spPr>
+          <a:xfrm>
+            <a:off x="457200" y="192024"/>
+            <a:ext cx="50292" cy="528320"/>
+          </a:xfrm>
+          <a:prstGeom prst="rect">
+            <a:avLst/>
+          </a:prstGeom>
+          <a:solidFill>
+            <a:srgbClr val="C9302C"/>
+          </a:solidFill>
+          <a:ln w="12700">
+            <a:solidFill>
+              <a:srgbClr val="C9302C"/>
+            </a:solidFill>
+            <a:prstDash val="solid"/>
+          </a:ln>
+        </p:spPr>
+      </p:sp>
+      <p:sp>
+        <p:nvSpPr>
+          <p:cNvPr id="9" name="slide-title:content"/>
           <p:cNvSpPr txBox="1"/>
           <p:nvPr/>
         </p:nvSpPr>
         <p:spPr>
           <a:xfrm>
-            <a:off x="457200" y="173736"/>
-            <a:ext cx="8229600" cy="528320"/>
+            <a:off x="640080" y="173736"/>
+            <a:ext cx="8046720" cy="528320"/>
           </a:xfrm>
           <a:prstGeom prst="rect">
             <a:avLst/>
@@ -4935,7 +5029,7 @@
                 <a:ea typeface="Helvetica Neue" pitchFamily="34" charset="-122"/>
                 <a:cs typeface="Helvetica Neue" pitchFamily="34" charset="-120"/>
               </a:rPr>
-              <a:t>Confusion counts, pooled over both executors</a:t>
+              <a:t>Confusion counts, executors pooled</a:t>
             </a:r>
             <a:endParaRPr lang="en-US" sz="2800" dirty="0"/>
           </a:p>
@@ -4943,14 +5037,39 @@
       </p:sp>
       <p:sp>
         <p:nvSpPr>
-          <p:cNvPr id="9" name="Shape 7"/>
+          <p:cNvPr id="10" name="Shape 8"/>
           <p:cNvSpPr/>
           <p:nvPr/>
         </p:nvSpPr>
         <p:spPr>
           <a:xfrm>
-            <a:off x="457200" y="50292"/>
-            <a:ext cx="8229600" cy="20117"/>
+            <a:off x="457200" y="756920"/>
+            <a:ext cx="8229600" cy="12802"/>
+          </a:xfrm>
+          <a:prstGeom prst="rect">
+            <a:avLst/>
+          </a:prstGeom>
+          <a:solidFill>
+            <a:srgbClr val="D1D5DB"/>
+          </a:solidFill>
+          <a:ln w="12700">
+            <a:solidFill>
+              <a:srgbClr val="D1D5DB"/>
+            </a:solidFill>
+            <a:prstDash val="solid"/>
+          </a:ln>
+        </p:spPr>
+      </p:sp>
+      <p:sp>
+        <p:nvSpPr>
+          <p:cNvPr id="11" name="Shape 9"/>
+          <p:cNvSpPr/>
+          <p:nvPr/>
+        </p:nvSpPr>
+        <p:spPr>
+          <a:xfrm>
+            <a:off x="457200" y="788010"/>
+            <a:ext cx="1097280" cy="23774"/>
           </a:xfrm>
           <a:prstGeom prst="rect">
             <a:avLst/>
@@ -4961,60 +5080,6 @@
           <a:ln w="12700">
             <a:solidFill>
               <a:srgbClr val="C9302C"/>
-            </a:solidFill>
-            <a:prstDash val="solid"/>
-          </a:ln>
-        </p:spPr>
-      </p:sp>
-      <p:sp>
-        <p:nvSpPr>
-          <p:cNvPr id="10" name="Shape 8"/>
-          <p:cNvSpPr/>
-          <p:nvPr/>
-        </p:nvSpPr>
-        <p:spPr>
-          <a:xfrm>
-            <a:off x="457200" y="70409"/>
-            <a:ext cx="8229600" cy="82296"/>
-          </a:xfrm>
-          <a:prstGeom prst="rect">
-            <a:avLst/>
-          </a:prstGeom>
-          <a:solidFill>
-            <a:srgbClr val="D1D5DB">
-              <a:alpha val="26000"/>
-            </a:srgbClr>
-          </a:solidFill>
-          <a:ln w="12700">
-            <a:solidFill>
-              <a:srgbClr val="D1D5DB">
-                <a:alpha val="0"/>
-              </a:srgbClr>
-            </a:solidFill>
-            <a:prstDash val="solid"/>
-          </a:ln>
-        </p:spPr>
-      </p:sp>
-      <p:sp>
-        <p:nvSpPr>
-          <p:cNvPr id="11" name="Shape 9"/>
-          <p:cNvSpPr/>
-          <p:nvPr/>
-        </p:nvSpPr>
-        <p:spPr>
-          <a:xfrm>
-            <a:off x="457200" y="756920"/>
-            <a:ext cx="8229600" cy="12802"/>
-          </a:xfrm>
-          <a:prstGeom prst="rect">
-            <a:avLst/>
-          </a:prstGeom>
-          <a:solidFill>
-            <a:srgbClr val="D1D5DB"/>
-          </a:solidFill>
-          <a:ln w="12700">
-            <a:solidFill>
-              <a:srgbClr val="D1D5DB"/>
             </a:solidFill>
             <a:prstDash val="solid"/>
           </a:ln>
@@ -5100,7 +5165,7 @@
       </p:sp>
       <p:graphicFrame>
         <p:nvGraphicFramePr>
-          <p:cNvPr id="6" name="Editable table: Confusion counts, pooled over both executors"/>
+          <p:cNvPr id="6" name="Editable table: Confusion counts, executors pooled"/>
           <p:cNvGraphicFramePr>
             <a:graphicFrameLocks noGrp="1"/>
           </p:cNvGraphicFramePr>
@@ -6263,7 +6328,7 @@
         <p:spPr>
           <a:xfrm>
             <a:off x="5340096" y="1049528"/>
-            <a:ext cx="36576" cy="1339088"/>
+            <a:ext cx="36576" cy="818896"/>
           </a:xfrm>
           <a:prstGeom prst="rect">
             <a:avLst/>
@@ -6312,7 +6377,7 @@
                 <a:ea typeface="Helvetica Neue" pitchFamily="34" charset="-122"/>
                 <a:cs typeface="Helvetica Neue" pitchFamily="34" charset="-120"/>
               </a:rPr>
-              <a:t>Pooled</a:t>
+              <a:t>Score only, pooled</a:t>
             </a:r>
             <a:endParaRPr lang="en-US" sz="1300" dirty="0"/>
           </a:p>
@@ -6327,7 +6392,7 @@
         <p:spPr>
           <a:xfrm>
             <a:off x="5468112" y="1471168"/>
-            <a:ext cx="3218688" cy="917448"/>
+            <a:ext cx="3218688" cy="397256"/>
           </a:xfrm>
           <a:prstGeom prst="rect">
             <a:avLst/>
@@ -6351,10 +6416,96 @@
                 <a:ea typeface="Helvetica Neue" pitchFamily="34" charset="-122"/>
                 <a:cs typeface="Helvetica Neue" pitchFamily="34" charset="-120"/>
               </a:rPr>
-              <a:t>Score only 0.5 (0.236 to</a:t>
+              <a:t>0.5 (0.236 to 0.767)</a:t>
             </a:r>
             <a:endParaRPr lang="en-US" sz="1600" dirty="0"/>
           </a:p>
+        </p:txBody>
+      </p:sp>
+      <p:sp>
+        <p:nvSpPr>
+          <p:cNvPr id="15" name="Shape 12"/>
+          <p:cNvSpPr/>
+          <p:nvPr/>
+        </p:nvSpPr>
+        <p:spPr>
+          <a:xfrm>
+            <a:off x="5340096" y="1996440"/>
+            <a:ext cx="36576" cy="818896"/>
+          </a:xfrm>
+          <a:prstGeom prst="rect">
+            <a:avLst/>
+          </a:prstGeom>
+          <a:solidFill>
+            <a:srgbClr val="C9302C"/>
+          </a:solidFill>
+          <a:ln w="12700">
+            <a:solidFill>
+              <a:srgbClr val="C9302C"/>
+            </a:solidFill>
+            <a:prstDash val="solid"/>
+          </a:ln>
+        </p:spPr>
+      </p:sp>
+      <p:sp>
+        <p:nvSpPr>
+          <p:cNvPr id="16" name="support:sidebar:1:title"/>
+          <p:cNvSpPr txBox="1"/>
+          <p:nvPr/>
+        </p:nvSpPr>
+        <p:spPr>
+          <a:xfrm>
+            <a:off x="5468112" y="1996440"/>
+            <a:ext cx="3218688" cy="348488"/>
+          </a:xfrm>
+          <a:prstGeom prst="rect">
+            <a:avLst/>
+          </a:prstGeom>
+          <a:noFill/>
+          <a:ln/>
+        </p:spPr>
+        <p:txBody>
+          <a:bodyPr wrap="square" lIns="0" tIns="0" rIns="0" bIns="0" rtlCol="0" anchor="t"/>
+          <a:lstStyle/>
+          <a:p>
+            <a:pPr algn="l" indent="0" marL="0">
+              <a:buNone/>
+            </a:pPr>
+            <a:r>
+              <a:rPr lang="en-US" sz="1300" b="1" dirty="0">
+                <a:solidFill>
+                  <a:srgbClr val="C9302C"/>
+                </a:solidFill>
+                <a:latin typeface="Helvetica Neue" pitchFamily="34" charset="0"/>
+                <a:ea typeface="Helvetica Neue" pitchFamily="34" charset="-122"/>
+                <a:cs typeface="Helvetica Neue" pitchFamily="34" charset="-120"/>
+              </a:rPr>
+              <a:t>Fact file, pooled</a:t>
+            </a:r>
+            <a:endParaRPr lang="en-US" sz="1300" dirty="0"/>
+          </a:p>
+        </p:txBody>
+      </p:sp>
+      <p:sp>
+        <p:nvSpPr>
+          <p:cNvPr id="17" name="sidebar:1:body"/>
+          <p:cNvSpPr txBox="1"/>
+          <p:nvPr/>
+        </p:nvSpPr>
+        <p:spPr>
+          <a:xfrm>
+            <a:off x="5468112" y="2418080"/>
+            <a:ext cx="3218688" cy="397256"/>
+          </a:xfrm>
+          <a:prstGeom prst="rect">
+            <a:avLst/>
+          </a:prstGeom>
+          <a:noFill/>
+          <a:ln/>
+        </p:spPr>
+        <p:txBody>
+          <a:bodyPr wrap="square" lIns="0" tIns="0" rIns="0" bIns="0" rtlCol="0" anchor="t"/>
+          <a:lstStyle/>
           <a:p>
             <a:pPr algn="l" indent="0" marL="0">
               <a:buNone/>
@@ -6368,10 +6519,96 @@
                 <a:ea typeface="Helvetica Neue" pitchFamily="34" charset="-122"/>
                 <a:cs typeface="Helvetica Neue" pitchFamily="34" charset="-120"/>
               </a:rPr>
-              <a:t>0.767); fact file 0.533</a:t>
+              <a:t>0.533 (0.375 to 0.75)</a:t>
             </a:r>
             <a:endParaRPr lang="en-US" sz="1600" dirty="0"/>
           </a:p>
+        </p:txBody>
+      </p:sp>
+      <p:sp>
+        <p:nvSpPr>
+          <p:cNvPr id="18" name="Shape 15"/>
+          <p:cNvSpPr/>
+          <p:nvPr/>
+        </p:nvSpPr>
+        <p:spPr>
+          <a:xfrm>
+            <a:off x="5340096" y="2943352"/>
+            <a:ext cx="36576" cy="818896"/>
+          </a:xfrm>
+          <a:prstGeom prst="rect">
+            <a:avLst/>
+          </a:prstGeom>
+          <a:solidFill>
+            <a:srgbClr val="0B2545"/>
+          </a:solidFill>
+          <a:ln w="12700">
+            <a:solidFill>
+              <a:srgbClr val="0B2545"/>
+            </a:solidFill>
+            <a:prstDash val="solid"/>
+          </a:ln>
+        </p:spPr>
+      </p:sp>
+      <p:sp>
+        <p:nvSpPr>
+          <p:cNvPr id="19" name="support:sidebar:2:title"/>
+          <p:cNvSpPr txBox="1"/>
+          <p:nvPr/>
+        </p:nvSpPr>
+        <p:spPr>
+          <a:xfrm>
+            <a:off x="5468112" y="2943352"/>
+            <a:ext cx="3218688" cy="348488"/>
+          </a:xfrm>
+          <a:prstGeom prst="rect">
+            <a:avLst/>
+          </a:prstGeom>
+          <a:noFill/>
+          <a:ln/>
+        </p:spPr>
+        <p:txBody>
+          <a:bodyPr wrap="square" lIns="0" tIns="0" rIns="0" bIns="0" rtlCol="0" anchor="t"/>
+          <a:lstStyle/>
+          <a:p>
+            <a:pPr algn="l" indent="0" marL="0">
+              <a:buNone/>
+            </a:pPr>
+            <a:r>
+              <a:rPr lang="en-US" sz="1300" b="1" dirty="0">
+                <a:solidFill>
+                  <a:srgbClr val="0B2545"/>
+                </a:solidFill>
+                <a:latin typeface="Helvetica Neue" pitchFamily="34" charset="0"/>
+                <a:ea typeface="Helvetica Neue" pitchFamily="34" charset="-122"/>
+                <a:cs typeface="Helvetica Neue" pitchFamily="34" charset="-120"/>
+              </a:rPr>
+              <a:t>McNemar exact p</a:t>
+            </a:r>
+            <a:endParaRPr lang="en-US" sz="1300" dirty="0"/>
+          </a:p>
+        </p:txBody>
+      </p:sp>
+      <p:sp>
+        <p:nvSpPr>
+          <p:cNvPr id="20" name="sidebar:2:body"/>
+          <p:cNvSpPr txBox="1"/>
+          <p:nvPr/>
+        </p:nvSpPr>
+        <p:spPr>
+          <a:xfrm>
+            <a:off x="5468112" y="3364992"/>
+            <a:ext cx="3218688" cy="397256"/>
+          </a:xfrm>
+          <a:prstGeom prst="rect">
+            <a:avLst/>
+          </a:prstGeom>
+          <a:noFill/>
+          <a:ln/>
+        </p:spPr>
+        <p:txBody>
+          <a:bodyPr wrap="square" lIns="0" tIns="0" rIns="0" bIns="0" rtlCol="0" anchor="t"/>
+          <a:lstStyle/>
           <a:p>
             <a:pPr algn="l" indent="0" marL="0">
               <a:buNone/>
@@ -6385,7 +6622,7 @@
                 <a:ea typeface="Helvetica Neue" pitchFamily="34" charset="-122"/>
                 <a:cs typeface="Helvetica Neue" pitchFamily="34" charset="-120"/>
               </a:rPr>
-              <a:t>(0.375 to 0.75)</a:t>
+              <a:t>0.6875; discordant 4 and 2</a:t>
             </a:r>
             <a:endParaRPr lang="en-US" sz="1600" dirty="0"/>
           </a:p>
@@ -6393,127 +6630,7 @@
       </p:sp>
       <p:sp>
         <p:nvSpPr>
-          <p:cNvPr id="15" name="Shape 12"/>
-          <p:cNvSpPr/>
-          <p:nvPr/>
-        </p:nvSpPr>
-        <p:spPr>
-          <a:xfrm>
-            <a:off x="5340096" y="2516632"/>
-            <a:ext cx="36576" cy="1078992"/>
-          </a:xfrm>
-          <a:prstGeom prst="rect">
-            <a:avLst/>
-          </a:prstGeom>
-          <a:solidFill>
-            <a:srgbClr val="C9302C"/>
-          </a:solidFill>
-          <a:ln w="12700">
-            <a:solidFill>
-              <a:srgbClr val="C9302C"/>
-            </a:solidFill>
-            <a:prstDash val="solid"/>
-          </a:ln>
-        </p:spPr>
-      </p:sp>
-      <p:sp>
-        <p:nvSpPr>
-          <p:cNvPr id="16" name="support:sidebar:1:title"/>
-          <p:cNvSpPr txBox="1"/>
-          <p:nvPr/>
-        </p:nvSpPr>
-        <p:spPr>
-          <a:xfrm>
-            <a:off x="5468112" y="2516632"/>
-            <a:ext cx="3218688" cy="348488"/>
-          </a:xfrm>
-          <a:prstGeom prst="rect">
-            <a:avLst/>
-          </a:prstGeom>
-          <a:noFill/>
-          <a:ln/>
-        </p:spPr>
-        <p:txBody>
-          <a:bodyPr wrap="square" lIns="0" tIns="0" rIns="0" bIns="0" rtlCol="0" anchor="t"/>
-          <a:lstStyle/>
-          <a:p>
-            <a:pPr algn="l" indent="0" marL="0">
-              <a:buNone/>
-            </a:pPr>
-            <a:r>
-              <a:rPr lang="en-US" sz="1300" b="1" dirty="0">
-                <a:solidFill>
-                  <a:srgbClr val="C9302C"/>
-                </a:solidFill>
-                <a:latin typeface="Helvetica Neue" pitchFamily="34" charset="0"/>
-                <a:ea typeface="Helvetica Neue" pitchFamily="34" charset="-122"/>
-                <a:cs typeface="Helvetica Neue" pitchFamily="34" charset="-120"/>
-              </a:rPr>
-              <a:t>McNemar</a:t>
-            </a:r>
-            <a:endParaRPr lang="en-US" sz="1300" dirty="0"/>
-          </a:p>
-        </p:txBody>
-      </p:sp>
-      <p:sp>
-        <p:nvSpPr>
-          <p:cNvPr id="17" name="sidebar:1:body"/>
-          <p:cNvSpPr txBox="1"/>
-          <p:nvPr/>
-        </p:nvSpPr>
-        <p:spPr>
-          <a:xfrm>
-            <a:off x="5468112" y="2938272"/>
-            <a:ext cx="3218688" cy="657352"/>
-          </a:xfrm>
-          <a:prstGeom prst="rect">
-            <a:avLst/>
-          </a:prstGeom>
-          <a:noFill/>
-          <a:ln/>
-        </p:spPr>
-        <p:txBody>
-          <a:bodyPr wrap="square" lIns="0" tIns="0" rIns="0" bIns="0" rtlCol="0" anchor="t"/>
-          <a:lstStyle/>
-          <a:p>
-            <a:pPr algn="l" indent="0" marL="0">
-              <a:buNone/>
-            </a:pPr>
-            <a:r>
-              <a:rPr lang="en-US" sz="1600" dirty="0">
-                <a:solidFill>
-                  <a:srgbClr val="1B2838"/>
-                </a:solidFill>
-                <a:latin typeface="Helvetica Neue" pitchFamily="34" charset="0"/>
-                <a:ea typeface="Helvetica Neue" pitchFamily="34" charset="-122"/>
-                <a:cs typeface="Helvetica Neue" pitchFamily="34" charset="-120"/>
-              </a:rPr>
-              <a:t>Exact p 0.6875 (4 for, 2</a:t>
-            </a:r>
-            <a:endParaRPr lang="en-US" sz="1600" dirty="0"/>
-          </a:p>
-          <a:p>
-            <a:pPr algn="l" indent="0" marL="0">
-              <a:buNone/>
-            </a:pPr>
-            <a:r>
-              <a:rPr lang="en-US" sz="1600" dirty="0">
-                <a:solidFill>
-                  <a:srgbClr val="1B2838"/>
-                </a:solidFill>
-                <a:latin typeface="Helvetica Neue" pitchFamily="34" charset="0"/>
-                <a:ea typeface="Helvetica Neue" pitchFamily="34" charset="-122"/>
-                <a:cs typeface="Helvetica Neue" pitchFamily="34" charset="-120"/>
-              </a:rPr>
-              <a:t>against)</a:t>
-            </a:r>
-            <a:endParaRPr lang="en-US" sz="1600" dirty="0"/>
-          </a:p>
-        </p:txBody>
-      </p:sp>
-      <p:sp>
-        <p:nvSpPr>
-          <p:cNvPr id="18" name="metadata:sidebar:caption"/>
+          <p:cNvPr id="21" name="metadata:sidebar:caption"/>
           <p:cNvSpPr txBox="1"/>
           <p:nvPr/>
         </p:nvSpPr>
@@ -6552,7 +6669,7 @@
       </p:sp>
       <p:sp>
         <p:nvSpPr>
-          <p:cNvPr id="19" name="Shape 16"/>
+          <p:cNvPr id="22" name="Shape 19"/>
           <p:cNvSpPr/>
           <p:nvPr/>
         </p:nvSpPr>
@@ -6577,7 +6694,7 @@
       </p:sp>
       <p:sp>
         <p:nvSpPr>
-          <p:cNvPr id="20" name="metadata:footer-sources"/>
+          <p:cNvPr id="23" name="metadata:footer-sources"/>
           <p:cNvSpPr txBox="1"/>
           <p:nvPr/>
         </p:nvSpPr>
@@ -6618,7 +6735,7 @@
       </p:sp>
       <p:sp>
         <p:nvSpPr>
-          <p:cNvPr id="21" name="metadata:footer-page-number"/>
+          <p:cNvPr id="24" name="metadata:footer-page-number"/>
           <p:cNvSpPr txBox="1"/>
           <p:nvPr/>
         </p:nvSpPr>
@@ -6977,7 +7094,7 @@
                 <a:ea typeface="Helvetica Neue" pitchFamily="34" charset="-122"/>
                 <a:cs typeface="Helvetica Neue" pitchFamily="34" charset="-120"/>
               </a:rPr>
-              <a:t>A</a:t>
+              <a:t>A. Ground truth and majority verdict per prediction</a:t>
             </a:r>
             <a:endParaRPr lang="en-US" sz="1300" dirty="0"/>
           </a:p>
@@ -7498,8 +7615,8 @@
         </p:nvSpPr>
         <p:spPr>
           <a:xfrm>
-            <a:off x="512064" y="1140968"/>
-            <a:ext cx="3840480" cy="397256"/>
+            <a:off x="603504" y="1232408"/>
+            <a:ext cx="3657600" cy="397256"/>
           </a:xfrm>
           <a:prstGeom prst="rect">
             <a:avLst/>
@@ -7537,8 +7654,8 @@
         </p:nvSpPr>
         <p:spPr>
           <a:xfrm>
-            <a:off x="512064" y="1629664"/>
-            <a:ext cx="3840480" cy="1437640"/>
+            <a:off x="603504" y="1721104"/>
+            <a:ext cx="3657600" cy="917448"/>
           </a:xfrm>
           <a:prstGeom prst="rect">
             <a:avLst/>
@@ -7562,7 +7679,7 @@
                 <a:ea typeface="Helvetica Neue" pitchFamily="34" charset="-122"/>
                 <a:cs typeface="Helvetica Neue" pitchFamily="34" charset="-120"/>
               </a:rPr>
-              <a:t>16 predictions of 4 systems, 2</a:t>
+              <a:t>16 predictions, 2 executors</a:t>
             </a:r>
             <a:endParaRPr lang="en-US" sz="1600" dirty="0"/>
           </a:p>
@@ -7579,7 +7696,7 @@
                 <a:ea typeface="Helvetica Neue" pitchFamily="34" charset="-122"/>
                 <a:cs typeface="Helvetica Neue" pitchFamily="34" charset="-120"/>
               </a:rPr>
-              <a:t>executors</a:t>
+              <a:t>Every prompt and response logged</a:t>
             </a:r>
             <a:endParaRPr lang="en-US" sz="1600" dirty="0"/>
           </a:p>
@@ -7596,41 +7713,7 @@
                 <a:ea typeface="Helvetica Neue" pitchFamily="34" charset="-122"/>
                 <a:cs typeface="Helvetica Neue" pitchFamily="34" charset="-120"/>
               </a:rPr>
-              <a:t>Every prompt and response recorded</a:t>
-            </a:r>
-            <a:endParaRPr lang="en-US" sz="1600" dirty="0"/>
-          </a:p>
-          <a:p>
-            <a:pPr algn="l" indent="0" marL="0">
-              <a:buNone/>
-            </a:pPr>
-            <a:r>
-              <a:rPr lang="en-US" sz="1600" dirty="0">
-                <a:solidFill>
-                  <a:srgbClr val="1B2838"/>
-                </a:solidFill>
-                <a:latin typeface="Helvetica Neue" pitchFamily="34" charset="0"/>
-                <a:ea typeface="Helvetica Neue" pitchFamily="34" charset="-122"/>
-                <a:cs typeface="Helvetica Neue" pitchFamily="34" charset="-120"/>
-              </a:rPr>
-              <a:t>Ground truth fixed before any</a:t>
-            </a:r>
-            <a:endParaRPr lang="en-US" sz="1600" dirty="0"/>
-          </a:p>
-          <a:p>
-            <a:pPr algn="l" indent="0" marL="0">
-              <a:buNone/>
-            </a:pPr>
-            <a:r>
-              <a:rPr lang="en-US" sz="1600" dirty="0">
-                <a:solidFill>
-                  <a:srgbClr val="1B2838"/>
-                </a:solidFill>
-                <a:latin typeface="Helvetica Neue" pitchFamily="34" charset="0"/>
-                <a:ea typeface="Helvetica Neue" pitchFamily="34" charset="-122"/>
-                <a:cs typeface="Helvetica Neue" pitchFamily="34" charset="-120"/>
-              </a:rPr>
-              <a:t>decision</a:t>
+              <a:t>Ground truth fixed in advance</a:t>
             </a:r>
             <a:endParaRPr lang="en-US" sz="1600" dirty="0"/>
           </a:p>
@@ -7709,7 +7792,7 @@
         <p:spPr>
           <a:xfrm>
             <a:off x="4882896" y="1721104"/>
-            <a:ext cx="3657600" cy="1437640"/>
+            <a:ext cx="3657600" cy="917448"/>
           </a:xfrm>
           <a:prstGeom prst="rect">
             <a:avLst/>
@@ -7733,7 +7816,7 @@
                 <a:ea typeface="Helvetica Neue" pitchFamily="34" charset="-122"/>
                 <a:cs typeface="Helvetica Neue" pitchFamily="34" charset="-120"/>
               </a:rPr>
-              <a:t>A statistical difference</a:t>
+              <a:t>A significant difference</a:t>
             </a:r>
             <a:endParaRPr lang="en-US" sz="1600" dirty="0"/>
           </a:p>
@@ -7750,7 +7833,7 @@
                 <a:ea typeface="Helvetica Neue" pitchFamily="34" charset="-122"/>
                 <a:cs typeface="Helvetica Neue" pitchFamily="34" charset="-120"/>
               </a:rPr>
-              <a:t>between arms</a:t>
+              <a:t>Loss of binding (assumed)</a:t>
             </a:r>
             <a:endParaRPr lang="en-US" sz="1600" dirty="0"/>
           </a:p>
@@ -7767,41 +7850,7 @@
                 <a:ea typeface="Helvetica Neue" pitchFamily="34" charset="-122"/>
                 <a:cs typeface="Helvetica Neue" pitchFamily="34" charset="-120"/>
               </a:rPr>
-              <a:t>Binding loss beyond the source</a:t>
-            </a:r>
-            <a:endParaRPr lang="en-US" sz="1600" dirty="0"/>
-          </a:p>
-          <a:p>
-            <a:pPr algn="l" indent="0" marL="0">
-              <a:buNone/>
-            </a:pPr>
-            <a:r>
-              <a:rPr lang="en-US" sz="1600" dirty="0">
-                <a:solidFill>
-                  <a:srgbClr val="1B2838"/>
-                </a:solidFill>
-                <a:latin typeface="Helvetica Neue" pitchFamily="34" charset="0"/>
-                <a:ea typeface="Helvetica Neue" pitchFamily="34" charset="-122"/>
-                <a:cs typeface="Helvetica Neue" pitchFamily="34" charset="-120"/>
-              </a:rPr>
-              <a:t>studies</a:t>
-            </a:r>
-            <a:endParaRPr lang="en-US" sz="1600" dirty="0"/>
-          </a:p>
-          <a:p>
-            <a:pPr algn="l" indent="0" marL="0">
-              <a:buNone/>
-            </a:pPr>
-            <a:r>
-              <a:rPr lang="en-US" sz="1600" dirty="0">
-                <a:solidFill>
-                  <a:srgbClr val="1B2838"/>
-                </a:solidFill>
-                <a:latin typeface="Helvetica Neue" pitchFamily="34" charset="0"/>
-                <a:ea typeface="Helvetica Neue" pitchFamily="34" charset="-122"/>
-                <a:cs typeface="Helvetica Neue" pitchFamily="34" charset="-120"/>
-              </a:rPr>
-              <a:t>Effect of prompt length alone</a:t>
+              <a:t>Effect of prompt length</a:t>
             </a:r>
             <a:endParaRPr lang="en-US" sz="1600" dirty="0"/>
           </a:p>

</xml_diff>

<commit_message>
bench: rebuild all three decks on the named-case layout, reviewed and bound
</commit_message>
<xml_diff>
--- a/bench/runs/2026-10-17T1611Z-426bfe9/results/deck.pptx
+++ b/bench/runs/2026-10-17T1611Z-426bfe9/results/deck.pptx
@@ -861,7 +861,7 @@
           <a:p>
             <a:r>
               <a:rPr lang="en-US" dirty="0"/>
-              <a:t/>
+              <a:t>Contact recovery is the signal that separates the states. Confidence and PoseBusters stay clean on the perturbed poses.</a:t>
             </a:r>
             <a:endParaRPr lang="en-US" dirty="0"/>
           </a:p>
@@ -949,7 +949,7 @@
           <a:p>
             <a:r>
               <a:rPr lang="en-US" dirty="0"/>
-              <a:t>Boltz-2: score only 0.5 (0.5 to 0.5), fact file 0.567 (0.25 to 0.929). DiffDock-L: score only 0.5 (0.5 to 0.5), fact file 0.5 (0.5 to 0.5).</a:t>
+              <a:t>Score only kept 5 of 10 invalid predictions; the fact file arm kept 1 of 6 valid.</a:t>
             </a:r>
             <a:endParaRPr lang="en-US" dirty="0"/>
           </a:p>
@@ -1037,7 +1037,7 @@
           <a:p>
             <a:r>
               <a:rPr lang="en-US" dirty="0"/>
-              <a:t>Score only kept 5 of 10 invalid predictions; the fact file arm kept 1 of 6 valid.</a:t>
+              <a:t>Boltz-2: score only 0.5 (0.5 to 0.5), fact file 0.567 (0.25 to 0.929). DiffDock-L: score only 0.5 (0.5 to 0.5), fact file 0.5 (0.5 to 0.5).</a:t>
             </a:r>
             <a:endParaRPr lang="en-US" dirty="0"/>
           </a:p>
@@ -4973,39 +4973,14 @@
       </p:sp>
       <p:sp>
         <p:nvSpPr>
-          <p:cNvPr id="8" name="Shape 6"/>
-          <p:cNvSpPr/>
-          <p:nvPr/>
-        </p:nvSpPr>
-        <p:spPr>
-          <a:xfrm>
-            <a:off x="457200" y="192024"/>
-            <a:ext cx="50292" cy="528320"/>
-          </a:xfrm>
-          <a:prstGeom prst="rect">
-            <a:avLst/>
-          </a:prstGeom>
-          <a:solidFill>
-            <a:srgbClr val="C9302C"/>
-          </a:solidFill>
-          <a:ln w="12700">
-            <a:solidFill>
-              <a:srgbClr val="C9302C"/>
-            </a:solidFill>
-            <a:prstDash val="solid"/>
-          </a:ln>
-        </p:spPr>
-      </p:sp>
-      <p:sp>
-        <p:nvSpPr>
-          <p:cNvPr id="9" name="slide-title:content"/>
+          <p:cNvPr id="8" name="slide-title:content"/>
           <p:cNvSpPr txBox="1"/>
           <p:nvPr/>
         </p:nvSpPr>
         <p:spPr>
           <a:xfrm>
-            <a:off x="640080" y="173736"/>
-            <a:ext cx="8046720" cy="528320"/>
+            <a:off x="457200" y="173736"/>
+            <a:ext cx="8229600" cy="528320"/>
           </a:xfrm>
           <a:prstGeom prst="rect">
             <a:avLst/>
@@ -5029,7 +5004,7 @@
                 <a:ea typeface="Helvetica Neue" pitchFamily="34" charset="-122"/>
                 <a:cs typeface="Helvetica Neue" pitchFamily="34" charset="-120"/>
               </a:rPr>
-              <a:t>Confusion counts, executors pooled</a:t>
+              <a:t>What the perturbation did, by system</a:t>
             </a:r>
             <a:endParaRPr lang="en-US" sz="2800" dirty="0"/>
           </a:p>
@@ -5037,13 +5012,106 @@
       </p:sp>
       <p:sp>
         <p:nvSpPr>
+          <p:cNvPr id="9" name="support:slide-subtitle"/>
+          <p:cNvSpPr txBox="1"/>
+          <p:nvPr/>
+        </p:nvSpPr>
+        <p:spPr>
+          <a:xfrm>
+            <a:off x="457200" y="738632"/>
+            <a:ext cx="8229600" cy="292608"/>
+          </a:xfrm>
+          <a:prstGeom prst="rect">
+            <a:avLst/>
+          </a:prstGeom>
+          <a:noFill/>
+          <a:ln/>
+        </p:spPr>
+        <p:txBody>
+          <a:bodyPr wrap="square" lIns="0" tIns="0" rIns="0" bIns="0" rtlCol="0" anchor="t"/>
+          <a:lstStyle/>
+          <a:p>
+            <a:pPr algn="l" indent="0" marL="0">
+              <a:buNone/>
+            </a:pPr>
+            <a:r>
+              <a:rPr lang="en-US" sz="1300" dirty="0">
+                <a:solidFill>
+                  <a:srgbClr val="4B5563"/>
+                </a:solidFill>
+                <a:latin typeface="Helvetica Neue" pitchFamily="34" charset="0"/>
+                <a:ea typeface="Helvetica Neue" pitchFamily="34" charset="-122"/>
+                <a:cs typeface="Helvetica Neue" pitchFamily="34" charset="-120"/>
+              </a:rPr>
+              <a:t>Deposited contacts the medoid reproduces, wild type against perturbed</a:t>
+            </a:r>
+            <a:endParaRPr lang="en-US" sz="1300" dirty="0"/>
+          </a:p>
+        </p:txBody>
+      </p:sp>
+      <p:sp>
+        <p:nvSpPr>
           <p:cNvPr id="10" name="Shape 8"/>
           <p:cNvSpPr/>
           <p:nvPr/>
         </p:nvSpPr>
         <p:spPr>
           <a:xfrm>
-            <a:off x="457200" y="756920"/>
+            <a:off x="457200" y="50292"/>
+            <a:ext cx="8229600" cy="20117"/>
+          </a:xfrm>
+          <a:prstGeom prst="rect">
+            <a:avLst/>
+          </a:prstGeom>
+          <a:solidFill>
+            <a:srgbClr val="C9302C"/>
+          </a:solidFill>
+          <a:ln w="12700">
+            <a:solidFill>
+              <a:srgbClr val="C9302C"/>
+            </a:solidFill>
+            <a:prstDash val="solid"/>
+          </a:ln>
+        </p:spPr>
+      </p:sp>
+      <p:sp>
+        <p:nvSpPr>
+          <p:cNvPr id="11" name="Shape 9"/>
+          <p:cNvSpPr/>
+          <p:nvPr/>
+        </p:nvSpPr>
+        <p:spPr>
+          <a:xfrm>
+            <a:off x="457200" y="70409"/>
+            <a:ext cx="8229600" cy="82296"/>
+          </a:xfrm>
+          <a:prstGeom prst="rect">
+            <a:avLst/>
+          </a:prstGeom>
+          <a:solidFill>
+            <a:srgbClr val="D1D5DB">
+              <a:alpha val="26000"/>
+            </a:srgbClr>
+          </a:solidFill>
+          <a:ln w="12700">
+            <a:solidFill>
+              <a:srgbClr val="D1D5DB">
+                <a:alpha val="0"/>
+              </a:srgbClr>
+            </a:solidFill>
+            <a:prstDash val="solid"/>
+          </a:ln>
+        </p:spPr>
+      </p:sp>
+      <p:sp>
+        <p:nvSpPr>
+          <p:cNvPr id="12" name="Shape 10"/>
+          <p:cNvSpPr/>
+          <p:nvPr/>
+        </p:nvSpPr>
+        <p:spPr>
+          <a:xfrm>
+            <a:off x="457200" y="1086104"/>
             <a:ext cx="8229600" cy="12802"/>
           </a:xfrm>
           <a:prstGeom prst="rect">
@@ -5062,38 +5130,13 @@
       </p:sp>
       <p:sp>
         <p:nvSpPr>
-          <p:cNvPr id="11" name="Shape 9"/>
-          <p:cNvSpPr/>
-          <p:nvPr/>
-        </p:nvSpPr>
-        <p:spPr>
-          <a:xfrm>
-            <a:off x="457200" y="788010"/>
-            <a:ext cx="1097280" cy="23774"/>
-          </a:xfrm>
-          <a:prstGeom prst="rect">
-            <a:avLst/>
-          </a:prstGeom>
-          <a:solidFill>
-            <a:srgbClr val="C9302C"/>
-          </a:solidFill>
-          <a:ln w="12700">
-            <a:solidFill>
-              <a:srgbClr val="C9302C"/>
-            </a:solidFill>
-            <a:prstDash val="solid"/>
-          </a:ln>
-        </p:spPr>
-      </p:sp>
-      <p:sp>
-        <p:nvSpPr>
-          <p:cNvPr id="12" name="metadata:table-index-label"/>
+          <p:cNvPr id="13" name="metadata:table-index-label"/>
           <p:cNvSpPr txBox="1"/>
           <p:nvPr/>
         </p:nvSpPr>
         <p:spPr>
           <a:xfrm>
-            <a:off x="566928" y="1159256"/>
+            <a:off x="566928" y="1488440"/>
             <a:ext cx="969264" cy="283464"/>
           </a:xfrm>
           <a:prstGeom prst="rect">
@@ -5126,13 +5169,13 @@
       </p:sp>
       <p:sp>
         <p:nvSpPr>
-          <p:cNvPr id="13" name="metadata:table-index-detail"/>
+          <p:cNvPr id="14" name="metadata:table-index-detail"/>
           <p:cNvSpPr txBox="1"/>
           <p:nvPr/>
         </p:nvSpPr>
         <p:spPr>
           <a:xfrm>
-            <a:off x="1645920" y="1159256"/>
+            <a:off x="1645920" y="1488440"/>
             <a:ext cx="6931152" cy="283464"/>
           </a:xfrm>
           <a:prstGeom prst="rect">
@@ -5157,7 +5200,7 @@
                 <a:ea typeface="Helvetica Neue" pitchFamily="34" charset="-122"/>
                 <a:cs typeface="Helvetica Neue" pitchFamily="34" charset="-120"/>
               </a:rPr>
-              <a:t>2 rows | Arm | Valid kept | Valid rejected | Invalid kept | Invalid rejected</a:t>
+              <a:t>4 rows | System | Wild type contacts | Perturbed contacts | Perturbed medoid (Å)</a:t>
             </a:r>
             <a:endParaRPr lang="en-US" sz="900" dirty="0"/>
           </a:p>
@@ -5165,7 +5208,7 @@
       </p:sp>
       <p:graphicFrame>
         <p:nvGraphicFramePr>
-          <p:cNvPr id="6" name="Editable table: Confusion counts, executors pooled"/>
+          <p:cNvPr id="6" name="Editable table: What the perturbation did, by system"/>
           <p:cNvGraphicFramePr>
             <a:graphicFrameLocks noGrp="1"/>
           </p:cNvGraphicFramePr>
@@ -5178,21 +5221,20 @@
           </p:nvPr>
         </p:nvGraphicFramePr>
         <p:xfrm>
-          <a:off x="457200" y="1688810"/>
-          <a:ext cx="8229600" cy="1876943"/>
+          <a:off x="457200" y="1962033"/>
+          <a:ext cx="8229600" cy="2277872"/>
         </p:xfrm>
         <a:graphic>
           <a:graphicData uri="http://schemas.openxmlformats.org/drawingml/2006/table">
             <a:tbl>
               <a:tblPr/>
               <a:tblGrid>
-                <a:gridCol w="1645920"/>
-                <a:gridCol w="1645920"/>
-                <a:gridCol w="1645920"/>
-                <a:gridCol w="1645920"/>
-                <a:gridCol w="1645920"/>
+                <a:gridCol w="2057400"/>
+                <a:gridCol w="2057400"/>
+                <a:gridCol w="2057400"/>
+                <a:gridCol w="2057400"/>
               </a:tblGrid>
-              <a:tr h="799045">
+              <a:tr h="611632">
                 <a:tc>
                   <a:txBody>
                     <a:bodyPr/>
@@ -5210,7 +5252,7 @@
                           <a:ea typeface="Helvetica Neue" pitchFamily="34" charset="-122"/>
                           <a:cs typeface="Helvetica Neue" pitchFamily="34" charset="-120"/>
                         </a:rPr>
-                        <a:t>Arm</a:t>
+                        <a:t>System</a:t>
                       </a:r>
                       <a:endParaRPr lang="en-US" sz="1600" dirty="0">
                         <a:latin typeface="Helvetica Neue" charset="0"/>
@@ -5254,7 +5296,7 @@
                           <a:ea typeface="Helvetica Neue" pitchFamily="34" charset="-122"/>
                           <a:cs typeface="Helvetica Neue" pitchFamily="34" charset="-120"/>
                         </a:rPr>
-                        <a:t>Valid kept</a:t>
+                        <a:t>Wild type contacts</a:t>
                       </a:r>
                       <a:endParaRPr lang="en-US" sz="1600" dirty="0">
                         <a:latin typeface="Helvetica Neue" charset="0"/>
@@ -5298,7 +5340,7 @@
                           <a:ea typeface="Helvetica Neue" pitchFamily="34" charset="-122"/>
                           <a:cs typeface="Helvetica Neue" pitchFamily="34" charset="-120"/>
                         </a:rPr>
-                        <a:t>Valid rejected</a:t>
+                        <a:t>Perturbed contacts</a:t>
                       </a:r>
                       <a:endParaRPr lang="en-US" sz="1600" dirty="0">
                         <a:latin typeface="Helvetica Neue" charset="0"/>
@@ -5342,7 +5384,7 @@
                           <a:ea typeface="Helvetica Neue" pitchFamily="34" charset="-122"/>
                           <a:cs typeface="Helvetica Neue" pitchFamily="34" charset="-120"/>
                         </a:rPr>
-                        <a:t>Invalid kept</a:t>
+                        <a:t>Perturbed medoid (Å)</a:t>
                       </a:r>
                       <a:endParaRPr lang="en-US" sz="1600" dirty="0">
                         <a:latin typeface="Helvetica Neue" charset="0"/>
@@ -5369,52 +5411,8 @@
                     </a:solidFill>
                   </a:tcPr>
                 </a:tc>
-                <a:tc>
-                  <a:txBody>
-                    <a:bodyPr/>
-                    <a:lstStyle/>
-                    <a:p>
-                      <a:pPr algn="l" indent="0" marL="0">
-                        <a:buNone/>
-                      </a:pPr>
-                      <a:r>
-                        <a:rPr lang="en-US" sz="1600" b="1" dirty="0">
-                          <a:solidFill>
-                            <a:srgbClr val="FFFFFF"/>
-                          </a:solidFill>
-                          <a:latin typeface="Helvetica Neue" pitchFamily="34" charset="0"/>
-                          <a:ea typeface="Helvetica Neue" pitchFamily="34" charset="-122"/>
-                          <a:cs typeface="Helvetica Neue" pitchFamily="34" charset="-120"/>
-                        </a:rPr>
-                        <a:t>Invalid rejected</a:t>
-                      </a:r>
-                      <a:endParaRPr lang="en-US" sz="1600" dirty="0">
-                        <a:latin typeface="Helvetica Neue" charset="0"/>
-                        <a:ea typeface="Helvetica Neue" charset="0"/>
-                        <a:cs typeface="Helvetica Neue" charset="0"/>
-                      </a:endParaRPr>
-                    </a:p>
-                  </a:txBody>
-                  <a:tcPr marL="36576" marR="36576" marT="36576" marB="36576" anchor="ctr">
-                    <a:lnL w="0" cap="flat" cmpd="sng" algn="ctr">
-                      <a:noFill/>
-                    </a:lnL>
-                    <a:lnR w="0" cap="flat" cmpd="sng" algn="ctr">
-                      <a:noFill/>
-                    </a:lnR>
-                    <a:lnT w="0" cap="flat" cmpd="sng" algn="ctr">
-                      <a:noFill/>
-                    </a:lnT>
-                    <a:lnB w="0" cap="flat" cmpd="sng" algn="ctr">
-                      <a:noFill/>
-                    </a:lnB>
-                    <a:solidFill>
-                      <a:srgbClr val="0B2545"/>
-                    </a:solidFill>
-                  </a:tcPr>
-                </a:tc>
               </a:tr>
-              <a:tr h="538949">
+              <a:tr h="351536">
                 <a:tc>
                   <a:txBody>
                     <a:bodyPr/>
@@ -5432,7 +5430,7 @@
                           <a:ea typeface="Helvetica Neue" pitchFamily="34" charset="-122"/>
                           <a:cs typeface="Helvetica Neue" pitchFamily="34" charset="-120"/>
                         </a:rPr>
-                        <a:t>Score only</a:t>
+                        <a:t>CDK2</a:t>
                       </a:r>
                       <a:endParaRPr lang="en-US" sz="1600" dirty="0">
                         <a:latin typeface="Helvetica Neue" charset="0"/>
@@ -5476,7 +5474,7 @@
                           <a:ea typeface="Helvetica Neue" pitchFamily="34" charset="-122"/>
                           <a:cs typeface="Helvetica Neue" pitchFamily="34" charset="-120"/>
                         </a:rPr>
-                        <a:t>3</a:t>
+                        <a:t>5 / 9 of 9</a:t>
                       </a:r>
                       <a:endParaRPr lang="en-US" sz="1600" dirty="0">
                         <a:latin typeface="Helvetica Neue" charset="0"/>
@@ -5520,7 +5518,7 @@
                           <a:ea typeface="Helvetica Neue" pitchFamily="34" charset="-122"/>
                           <a:cs typeface="Helvetica Neue" pitchFamily="34" charset="-120"/>
                         </a:rPr>
-                        <a:t>3</a:t>
+                        <a:t>1 / 0 of 9</a:t>
                       </a:r>
                       <a:endParaRPr lang="en-US" sz="1600" dirty="0">
                         <a:latin typeface="Helvetica Neue" charset="0"/>
@@ -5564,7 +5562,53 @@
                           <a:ea typeface="Helvetica Neue" pitchFamily="34" charset="-122"/>
                           <a:cs typeface="Helvetica Neue" pitchFamily="34" charset="-120"/>
                         </a:rPr>
-                        <a:t>5</a:t>
+                        <a:t>2.392 / 0.918</a:t>
+                      </a:r>
+                      <a:endParaRPr lang="en-US" sz="1600" dirty="0">
+                        <a:latin typeface="Helvetica Neue" charset="0"/>
+                        <a:ea typeface="Helvetica Neue" charset="0"/>
+                        <a:cs typeface="Helvetica Neue" charset="0"/>
+                      </a:endParaRPr>
+                    </a:p>
+                  </a:txBody>
+                  <a:tcPr marL="36576" marR="36576" marT="36576" marB="36576" anchor="ctr">
+                    <a:lnL w="0" cap="flat" cmpd="sng" algn="ctr">
+                      <a:noFill/>
+                    </a:lnL>
+                    <a:lnR w="0" cap="flat" cmpd="sng" algn="ctr">
+                      <a:noFill/>
+                    </a:lnR>
+                    <a:lnT w="0" cap="flat" cmpd="sng" algn="ctr">
+                      <a:noFill/>
+                    </a:lnT>
+                    <a:lnB w="0" cap="flat" cmpd="sng" algn="ctr">
+                      <a:noFill/>
+                    </a:lnB>
+                    <a:solidFill>
+                      <a:srgbClr val="FFFFFF"/>
+                    </a:solidFill>
+                  </a:tcPr>
+                </a:tc>
+              </a:tr>
+              <a:tr h="351536">
+                <a:tc>
+                  <a:txBody>
+                    <a:bodyPr/>
+                    <a:lstStyle/>
+                    <a:p>
+                      <a:pPr algn="l" indent="0" marL="0">
+                        <a:buNone/>
+                      </a:pPr>
+                      <a:r>
+                        <a:rPr lang="en-US" sz="1600" dirty="0">
+                          <a:solidFill>
+                            <a:srgbClr val="1B2838"/>
+                          </a:solidFill>
+                          <a:latin typeface="Helvetica Neue" pitchFamily="34" charset="0"/>
+                          <a:ea typeface="Helvetica Neue" pitchFamily="34" charset="-122"/>
+                          <a:cs typeface="Helvetica Neue" pitchFamily="34" charset="-120"/>
+                        </a:rPr>
+                        <a:t>FtsE</a:t>
                       </a:r>
                       <a:endParaRPr lang="en-US" sz="1600" dirty="0">
                         <a:latin typeface="Helvetica Neue" charset="0"/>
@@ -5608,53 +5652,7 @@
                           <a:ea typeface="Helvetica Neue" pitchFamily="34" charset="-122"/>
                           <a:cs typeface="Helvetica Neue" pitchFamily="34" charset="-120"/>
                         </a:rPr>
-                        <a:t>5</a:t>
-                      </a:r>
-                      <a:endParaRPr lang="en-US" sz="1600" dirty="0">
-                        <a:latin typeface="Helvetica Neue" charset="0"/>
-                        <a:ea typeface="Helvetica Neue" charset="0"/>
-                        <a:cs typeface="Helvetica Neue" charset="0"/>
-                      </a:endParaRPr>
-                    </a:p>
-                  </a:txBody>
-                  <a:tcPr marL="36576" marR="36576" marT="36576" marB="36576" anchor="ctr">
-                    <a:lnL w="0" cap="flat" cmpd="sng" algn="ctr">
-                      <a:noFill/>
-                    </a:lnL>
-                    <a:lnR w="0" cap="flat" cmpd="sng" algn="ctr">
-                      <a:noFill/>
-                    </a:lnR>
-                    <a:lnT w="0" cap="flat" cmpd="sng" algn="ctr">
-                      <a:noFill/>
-                    </a:lnT>
-                    <a:lnB w="0" cap="flat" cmpd="sng" algn="ctr">
-                      <a:noFill/>
-                    </a:lnB>
-                    <a:solidFill>
-                      <a:srgbClr val="FFFFFF"/>
-                    </a:solidFill>
-                  </a:tcPr>
-                </a:tc>
-              </a:tr>
-              <a:tr h="538949">
-                <a:tc>
-                  <a:txBody>
-                    <a:bodyPr/>
-                    <a:lstStyle/>
-                    <a:p>
-                      <a:pPr algn="l" indent="0" marL="0">
-                        <a:buNone/>
-                      </a:pPr>
-                      <a:r>
-                        <a:rPr lang="en-US" sz="1600" dirty="0">
-                          <a:solidFill>
-                            <a:srgbClr val="1B2838"/>
-                          </a:solidFill>
-                          <a:latin typeface="Helvetica Neue" pitchFamily="34" charset="0"/>
-                          <a:ea typeface="Helvetica Neue" pitchFamily="34" charset="-122"/>
-                          <a:cs typeface="Helvetica Neue" pitchFamily="34" charset="-120"/>
-                        </a:rPr>
-                        <a:t>Fact file</a:t>
+                        <a:t>9 / 10 of 16</a:t>
                       </a:r>
                       <a:endParaRPr lang="en-US" sz="1600" dirty="0">
                         <a:latin typeface="Helvetica Neue" charset="0"/>
@@ -5698,7 +5696,7 @@
                           <a:ea typeface="Helvetica Neue" pitchFamily="34" charset="-122"/>
                           <a:cs typeface="Helvetica Neue" pitchFamily="34" charset="-120"/>
                         </a:rPr>
-                        <a:t>1</a:t>
+                        <a:t>0 / 0 of 16</a:t>
                       </a:r>
                       <a:endParaRPr lang="en-US" sz="1600" dirty="0">
                         <a:latin typeface="Helvetica Neue" charset="0"/>
@@ -5742,7 +5740,53 @@
                           <a:ea typeface="Helvetica Neue" pitchFamily="34" charset="-122"/>
                           <a:cs typeface="Helvetica Neue" pitchFamily="34" charset="-120"/>
                         </a:rPr>
-                        <a:t>5</a:t>
+                        <a:t>15.415 / 17.74</a:t>
+                      </a:r>
+                      <a:endParaRPr lang="en-US" sz="1600" dirty="0">
+                        <a:latin typeface="Helvetica Neue" charset="0"/>
+                        <a:ea typeface="Helvetica Neue" charset="0"/>
+                        <a:cs typeface="Helvetica Neue" charset="0"/>
+                      </a:endParaRPr>
+                    </a:p>
+                  </a:txBody>
+                  <a:tcPr marL="36576" marR="36576" marT="36576" marB="36576" anchor="ctr">
+                    <a:lnL w="0" cap="flat" cmpd="sng" algn="ctr">
+                      <a:noFill/>
+                    </a:lnL>
+                    <a:lnR w="0" cap="flat" cmpd="sng" algn="ctr">
+                      <a:noFill/>
+                    </a:lnR>
+                    <a:lnT w="0" cap="flat" cmpd="sng" algn="ctr">
+                      <a:noFill/>
+                    </a:lnT>
+                    <a:lnB w="0" cap="flat" cmpd="sng" algn="ctr">
+                      <a:noFill/>
+                    </a:lnB>
+                    <a:solidFill>
+                      <a:srgbClr val="FFFFFF"/>
+                    </a:solidFill>
+                  </a:tcPr>
+                </a:tc>
+              </a:tr>
+              <a:tr h="611632">
+                <a:tc>
+                  <a:txBody>
+                    <a:bodyPr/>
+                    <a:lstStyle/>
+                    <a:p>
+                      <a:pPr algn="l" indent="0" marL="0">
+                        <a:buNone/>
+                      </a:pPr>
+                      <a:r>
+                        <a:rPr lang="en-US" sz="1600" dirty="0">
+                          <a:solidFill>
+                            <a:srgbClr val="1B2838"/>
+                          </a:solidFill>
+                          <a:latin typeface="Helvetica Neue" pitchFamily="34" charset="0"/>
+                          <a:ea typeface="Helvetica Neue" pitchFamily="34" charset="-122"/>
+                          <a:cs typeface="Helvetica Neue" pitchFamily="34" charset="-120"/>
+                        </a:rPr>
+                        <a:t>glucose dehydrogenase</a:t>
                       </a:r>
                       <a:endParaRPr lang="en-US" sz="1600" dirty="0">
                         <a:latin typeface="Helvetica Neue" charset="0"/>
@@ -5786,7 +5830,7 @@
                           <a:ea typeface="Helvetica Neue" pitchFamily="34" charset="-122"/>
                           <a:cs typeface="Helvetica Neue" pitchFamily="34" charset="-120"/>
                         </a:rPr>
-                        <a:t>1</a:t>
+                        <a:t>4 / 0 of 6</a:t>
                       </a:r>
                       <a:endParaRPr lang="en-US" sz="1600" dirty="0">
                         <a:latin typeface="Helvetica Neue" charset="0"/>
@@ -5830,7 +5874,229 @@
                           <a:ea typeface="Helvetica Neue" pitchFamily="34" charset="-122"/>
                           <a:cs typeface="Helvetica Neue" pitchFamily="34" charset="-120"/>
                         </a:rPr>
-                        <a:t>9</a:t>
+                        <a:t>3 / 0 of 6</a:t>
+                      </a:r>
+                      <a:endParaRPr lang="en-US" sz="1600" dirty="0">
+                        <a:latin typeface="Helvetica Neue" charset="0"/>
+                        <a:ea typeface="Helvetica Neue" charset="0"/>
+                        <a:cs typeface="Helvetica Neue" charset="0"/>
+                      </a:endParaRPr>
+                    </a:p>
+                  </a:txBody>
+                  <a:tcPr marL="36576" marR="36576" marT="36576" marB="36576" anchor="ctr">
+                    <a:lnL w="0" cap="flat" cmpd="sng" algn="ctr">
+                      <a:noFill/>
+                    </a:lnL>
+                    <a:lnR w="0" cap="flat" cmpd="sng" algn="ctr">
+                      <a:noFill/>
+                    </a:lnR>
+                    <a:lnT w="0" cap="flat" cmpd="sng" algn="ctr">
+                      <a:noFill/>
+                    </a:lnT>
+                    <a:lnB w="0" cap="flat" cmpd="sng" algn="ctr">
+                      <a:noFill/>
+                    </a:lnB>
+                    <a:solidFill>
+                      <a:srgbClr val="FFFFFF"/>
+                    </a:solidFill>
+                  </a:tcPr>
+                </a:tc>
+                <a:tc>
+                  <a:txBody>
+                    <a:bodyPr/>
+                    <a:lstStyle/>
+                    <a:p>
+                      <a:pPr algn="l" indent="0" marL="0">
+                        <a:buNone/>
+                      </a:pPr>
+                      <a:r>
+                        <a:rPr lang="en-US" sz="1600" dirty="0">
+                          <a:solidFill>
+                            <a:srgbClr val="1B2838"/>
+                          </a:solidFill>
+                          <a:latin typeface="Helvetica Neue" pitchFamily="34" charset="0"/>
+                          <a:ea typeface="Helvetica Neue" pitchFamily="34" charset="-122"/>
+                          <a:cs typeface="Helvetica Neue" pitchFamily="34" charset="-120"/>
+                        </a:rPr>
+                        <a:t>n/a / n/a</a:t>
+                      </a:r>
+                      <a:endParaRPr lang="en-US" sz="1600" dirty="0">
+                        <a:latin typeface="Helvetica Neue" charset="0"/>
+                        <a:ea typeface="Helvetica Neue" charset="0"/>
+                        <a:cs typeface="Helvetica Neue" charset="0"/>
+                      </a:endParaRPr>
+                    </a:p>
+                  </a:txBody>
+                  <a:tcPr marL="36576" marR="36576" marT="36576" marB="36576" anchor="ctr">
+                    <a:lnL w="0" cap="flat" cmpd="sng" algn="ctr">
+                      <a:noFill/>
+                    </a:lnL>
+                    <a:lnR w="0" cap="flat" cmpd="sng" algn="ctr">
+                      <a:noFill/>
+                    </a:lnR>
+                    <a:lnT w="0" cap="flat" cmpd="sng" algn="ctr">
+                      <a:noFill/>
+                    </a:lnT>
+                    <a:lnB w="0" cap="flat" cmpd="sng" algn="ctr">
+                      <a:noFill/>
+                    </a:lnB>
+                    <a:solidFill>
+                      <a:srgbClr val="FFFFFF"/>
+                    </a:solidFill>
+                  </a:tcPr>
+                </a:tc>
+              </a:tr>
+              <a:tr h="351536">
+                <a:tc>
+                  <a:txBody>
+                    <a:bodyPr/>
+                    <a:lstStyle/>
+                    <a:p>
+                      <a:pPr algn="l" indent="0" marL="0">
+                        <a:buNone/>
+                      </a:pPr>
+                      <a:r>
+                        <a:rPr lang="en-US" sz="1600" dirty="0">
+                          <a:solidFill>
+                            <a:srgbClr val="1B2838"/>
+                          </a:solidFill>
+                          <a:latin typeface="Helvetica Neue" pitchFamily="34" charset="0"/>
+                          <a:ea typeface="Helvetica Neue" pitchFamily="34" charset="-122"/>
+                          <a:cs typeface="Helvetica Neue" pitchFamily="34" charset="-120"/>
+                        </a:rPr>
+                        <a:t>MEK1</a:t>
+                      </a:r>
+                      <a:endParaRPr lang="en-US" sz="1600" dirty="0">
+                        <a:latin typeface="Helvetica Neue" charset="0"/>
+                        <a:ea typeface="Helvetica Neue" charset="0"/>
+                        <a:cs typeface="Helvetica Neue" charset="0"/>
+                      </a:endParaRPr>
+                    </a:p>
+                  </a:txBody>
+                  <a:tcPr marL="36576" marR="36576" marT="36576" marB="36576" anchor="ctr">
+                    <a:lnL w="0" cap="flat" cmpd="sng" algn="ctr">
+                      <a:noFill/>
+                    </a:lnL>
+                    <a:lnR w="0" cap="flat" cmpd="sng" algn="ctr">
+                      <a:noFill/>
+                    </a:lnR>
+                    <a:lnT w="0" cap="flat" cmpd="sng" algn="ctr">
+                      <a:noFill/>
+                    </a:lnT>
+                    <a:lnB w="0" cap="flat" cmpd="sng" algn="ctr">
+                      <a:noFill/>
+                    </a:lnB>
+                    <a:solidFill>
+                      <a:srgbClr val="FFFFFF"/>
+                    </a:solidFill>
+                  </a:tcPr>
+                </a:tc>
+                <a:tc>
+                  <a:txBody>
+                    <a:bodyPr/>
+                    <a:lstStyle/>
+                    <a:p>
+                      <a:pPr algn="l" indent="0" marL="0">
+                        <a:buNone/>
+                      </a:pPr>
+                      <a:r>
+                        <a:rPr lang="en-US" sz="1600" dirty="0">
+                          <a:solidFill>
+                            <a:srgbClr val="1B2838"/>
+                          </a:solidFill>
+                          <a:latin typeface="Helvetica Neue" pitchFamily="34" charset="0"/>
+                          <a:ea typeface="Helvetica Neue" pitchFamily="34" charset="-122"/>
+                          <a:cs typeface="Helvetica Neue" pitchFamily="34" charset="-120"/>
+                        </a:rPr>
+                        <a:t>2 / 2 of 3</a:t>
+                      </a:r>
+                      <a:endParaRPr lang="en-US" sz="1600" dirty="0">
+                        <a:latin typeface="Helvetica Neue" charset="0"/>
+                        <a:ea typeface="Helvetica Neue" charset="0"/>
+                        <a:cs typeface="Helvetica Neue" charset="0"/>
+                      </a:endParaRPr>
+                    </a:p>
+                  </a:txBody>
+                  <a:tcPr marL="36576" marR="36576" marT="36576" marB="36576" anchor="ctr">
+                    <a:lnL w="0" cap="flat" cmpd="sng" algn="ctr">
+                      <a:noFill/>
+                    </a:lnL>
+                    <a:lnR w="0" cap="flat" cmpd="sng" algn="ctr">
+                      <a:noFill/>
+                    </a:lnR>
+                    <a:lnT w="0" cap="flat" cmpd="sng" algn="ctr">
+                      <a:noFill/>
+                    </a:lnT>
+                    <a:lnB w="0" cap="flat" cmpd="sng" algn="ctr">
+                      <a:noFill/>
+                    </a:lnB>
+                    <a:solidFill>
+                      <a:srgbClr val="FFFFFF"/>
+                    </a:solidFill>
+                  </a:tcPr>
+                </a:tc>
+                <a:tc>
+                  <a:txBody>
+                    <a:bodyPr/>
+                    <a:lstStyle/>
+                    <a:p>
+                      <a:pPr algn="l" indent="0" marL="0">
+                        <a:buNone/>
+                      </a:pPr>
+                      <a:r>
+                        <a:rPr lang="en-US" sz="1600" dirty="0">
+                          <a:solidFill>
+                            <a:srgbClr val="1B2838"/>
+                          </a:solidFill>
+                          <a:latin typeface="Helvetica Neue" pitchFamily="34" charset="0"/>
+                          <a:ea typeface="Helvetica Neue" pitchFamily="34" charset="-122"/>
+                          <a:cs typeface="Helvetica Neue" pitchFamily="34" charset="-120"/>
+                        </a:rPr>
+                        <a:t>0 / 0 of 3</a:t>
+                      </a:r>
+                      <a:endParaRPr lang="en-US" sz="1600" dirty="0">
+                        <a:latin typeface="Helvetica Neue" charset="0"/>
+                        <a:ea typeface="Helvetica Neue" charset="0"/>
+                        <a:cs typeface="Helvetica Neue" charset="0"/>
+                      </a:endParaRPr>
+                    </a:p>
+                  </a:txBody>
+                  <a:tcPr marL="36576" marR="36576" marT="36576" marB="36576" anchor="ctr">
+                    <a:lnL w="0" cap="flat" cmpd="sng" algn="ctr">
+                      <a:noFill/>
+                    </a:lnL>
+                    <a:lnR w="0" cap="flat" cmpd="sng" algn="ctr">
+                      <a:noFill/>
+                    </a:lnR>
+                    <a:lnT w="0" cap="flat" cmpd="sng" algn="ctr">
+                      <a:noFill/>
+                    </a:lnT>
+                    <a:lnB w="0" cap="flat" cmpd="sng" algn="ctr">
+                      <a:noFill/>
+                    </a:lnB>
+                    <a:solidFill>
+                      <a:srgbClr val="FFFFFF"/>
+                    </a:solidFill>
+                  </a:tcPr>
+                </a:tc>
+                <a:tc>
+                  <a:txBody>
+                    <a:bodyPr/>
+                    <a:lstStyle/>
+                    <a:p>
+                      <a:pPr algn="l" indent="0" marL="0">
+                        <a:buNone/>
+                      </a:pPr>
+                      <a:r>
+                        <a:rPr lang="en-US" sz="1600" dirty="0">
+                          <a:solidFill>
+                            <a:srgbClr val="1B2838"/>
+                          </a:solidFill>
+                          <a:latin typeface="Helvetica Neue" pitchFamily="34" charset="0"/>
+                          <a:ea typeface="Helvetica Neue" pitchFamily="34" charset="-122"/>
+                          <a:cs typeface="Helvetica Neue" pitchFamily="34" charset="-120"/>
+                        </a:rPr>
+                        <a:t>3.036 / 1.463</a:t>
                       </a:r>
                       <a:endParaRPr lang="en-US" sz="1600" dirty="0">
                         <a:latin typeface="Helvetica Neue" charset="0"/>
@@ -5864,13 +6130,13 @@
       </p:graphicFrame>
       <p:sp>
         <p:nvSpPr>
-          <p:cNvPr id="15" name="metadata:table-caption"/>
+          <p:cNvPr id="16" name="metadata:table-caption"/>
           <p:cNvSpPr txBox="1"/>
           <p:nvPr/>
         </p:nvSpPr>
         <p:spPr>
           <a:xfrm>
-            <a:off x="457200" y="3638906"/>
+            <a:off x="457200" y="4313057"/>
             <a:ext cx="8229600" cy="283464"/>
           </a:xfrm>
           <a:prstGeom prst="rect">
@@ -5895,7 +6161,7 @@
                 <a:ea typeface="Helvetica Neue" pitchFamily="34" charset="-122"/>
                 <a:cs typeface="Helvetica Neue" pitchFamily="34" charset="-120"/>
               </a:rPr>
-              <a:t>16 predictions (6 valid, 10 invalid); majority verdict over three repeats.</a:t>
+              <a:t>Each cell Boltz-2 / DiffDock-L. Medoid RMSD is to the deposited ligand; n/a where the perturbation modifies the ligand.</a:t>
             </a:r>
             <a:endParaRPr lang="en-US" sz="900" dirty="0"/>
           </a:p>
@@ -5903,7 +6169,7 @@
       </p:sp>
       <p:sp>
         <p:nvSpPr>
-          <p:cNvPr id="16" name="Shape 13"/>
+          <p:cNvPr id="17" name="Shape 14"/>
           <p:cNvSpPr/>
           <p:nvPr/>
         </p:nvSpPr>
@@ -5928,7 +6194,7 @@
       </p:sp>
       <p:sp>
         <p:nvSpPr>
-          <p:cNvPr id="17" name="metadata:footer-sources"/>
+          <p:cNvPr id="18" name="metadata:footer-sources"/>
           <p:cNvSpPr txBox="1"/>
           <p:nvPr/>
         </p:nvSpPr>
@@ -5969,7 +6235,7 @@
       </p:sp>
       <p:sp>
         <p:nvSpPr>
-          <p:cNvPr id="18" name="metadata:footer-page-number"/>
+          <p:cNvPr id="19" name="metadata:footer-page-number"/>
           <p:cNvSpPr txBox="1"/>
           <p:nvPr/>
         </p:nvSpPr>
@@ -6239,7 +6505,7 @@
                 <a:ea typeface="Helvetica Neue" pitchFamily="34" charset="-122"/>
                 <a:cs typeface="Helvetica Neue" pitchFamily="34" charset="-120"/>
               </a:rPr>
-              <a:t>Balanced accuracy with 95% intervals</a:t>
+              <a:t>Decision per prediction</a:t>
             </a:r>
             <a:endParaRPr lang="en-US" sz="2800" dirty="0"/>
           </a:p>
@@ -6295,9 +6561,48 @@
           </a:ln>
         </p:spPr>
       </p:sp>
+      <p:sp>
+        <p:nvSpPr>
+          <p:cNvPr id="11" name="support:scientific:A:title"/>
+          <p:cNvSpPr txBox="1"/>
+          <p:nvPr/>
+        </p:nvSpPr>
+        <p:spPr>
+          <a:xfrm>
+            <a:off x="530352" y="1113536"/>
+            <a:ext cx="8083296" cy="348488"/>
+          </a:xfrm>
+          <a:prstGeom prst="rect">
+            <a:avLst/>
+          </a:prstGeom>
+          <a:noFill/>
+          <a:ln/>
+        </p:spPr>
+        <p:txBody>
+          <a:bodyPr wrap="square" lIns="0" tIns="0" rIns="0" bIns="0" rtlCol="0" anchor="t"/>
+          <a:lstStyle/>
+          <a:p>
+            <a:pPr algn="l" indent="0" marL="0">
+              <a:buNone/>
+            </a:pPr>
+            <a:r>
+              <a:rPr lang="en-US" sz="1300" b="1" dirty="0">
+                <a:solidFill>
+                  <a:srgbClr val="1B2838"/>
+                </a:solidFill>
+                <a:latin typeface="Helvetica Neue" pitchFamily="34" charset="0"/>
+                <a:ea typeface="Helvetica Neue" pitchFamily="34" charset="-122"/>
+                <a:cs typeface="Helvetica Neue" pitchFamily="34" charset="-120"/>
+              </a:rPr>
+              <a:t>A. Ground truth and majority verdict per prediction</a:t>
+            </a:r>
+            <a:endParaRPr lang="en-US" sz="1300" dirty="0"/>
+          </a:p>
+        </p:txBody>
+      </p:sp>
       <p:pic>
         <p:nvPicPr>
-          <p:cNvPr id="11" name="sidebar:figure" descr="Bootstrap over predictions; dashed line at 0.5.">    </p:cNvPr>
+          <p:cNvPr id="12" name="scientific:A:image" descr="B2 Boltz-2, DD DiffDock-L. V valid, I invalid.">    </p:cNvPr>
           <p:cNvPicPr>
             <a:picLocks noChangeAspect="1"/>
           </p:cNvPicPr>
@@ -6311,8 +6616,8 @@
         </p:blipFill>
         <p:spPr>
           <a:xfrm>
-            <a:off x="457200" y="1232132"/>
-            <a:ext cx="4608576" cy="2805220"/>
+            <a:off x="512064" y="1542930"/>
+            <a:ext cx="8119872" cy="2308591"/>
           </a:xfrm>
           <a:prstGeom prst="rect">
             <a:avLst/>
@@ -6321,78 +6626,14 @@
       </p:pic>
       <p:sp>
         <p:nvSpPr>
-          <p:cNvPr id="12" name="Shape 9"/>
-          <p:cNvSpPr/>
-          <p:nvPr/>
-        </p:nvSpPr>
-        <p:spPr>
-          <a:xfrm>
-            <a:off x="5340096" y="1049528"/>
-            <a:ext cx="36576" cy="818896"/>
-          </a:xfrm>
-          <a:prstGeom prst="rect">
-            <a:avLst/>
-          </a:prstGeom>
-          <a:solidFill>
-            <a:srgbClr val="0B2545"/>
-          </a:solidFill>
-          <a:ln w="12700">
-            <a:solidFill>
-              <a:srgbClr val="0B2545"/>
-            </a:solidFill>
-            <a:prstDash val="solid"/>
-          </a:ln>
-        </p:spPr>
-      </p:sp>
-      <p:sp>
-        <p:nvSpPr>
-          <p:cNvPr id="13" name="support:sidebar:0:title"/>
+          <p:cNvPr id="13" name="scientific:complete-readout"/>
           <p:cNvSpPr txBox="1"/>
           <p:nvPr/>
         </p:nvSpPr>
         <p:spPr>
           <a:xfrm>
-            <a:off x="5468112" y="1049528"/>
-            <a:ext cx="3218688" cy="348488"/>
-          </a:xfrm>
-          <a:prstGeom prst="rect">
-            <a:avLst/>
-          </a:prstGeom>
-          <a:noFill/>
-          <a:ln/>
-        </p:spPr>
-        <p:txBody>
-          <a:bodyPr wrap="square" lIns="0" tIns="0" rIns="0" bIns="0" rtlCol="0" anchor="t"/>
-          <a:lstStyle/>
-          <a:p>
-            <a:pPr algn="l" indent="0" marL="0">
-              <a:buNone/>
-            </a:pPr>
-            <a:r>
-              <a:rPr lang="en-US" sz="1300" b="1" dirty="0">
-                <a:solidFill>
-                  <a:srgbClr val="0B2545"/>
-                </a:solidFill>
-                <a:latin typeface="Helvetica Neue" pitchFamily="34" charset="0"/>
-                <a:ea typeface="Helvetica Neue" pitchFamily="34" charset="-122"/>
-                <a:cs typeface="Helvetica Neue" pitchFamily="34" charset="-120"/>
-              </a:rPr>
-              <a:t>Score only, pooled</a:t>
-            </a:r>
-            <a:endParaRPr lang="en-US" sz="1300" dirty="0"/>
-          </a:p>
-        </p:txBody>
-      </p:sp>
-      <p:sp>
-        <p:nvSpPr>
-          <p:cNvPr id="14" name="sidebar:0:body"/>
-          <p:cNvSpPr txBox="1"/>
-          <p:nvPr/>
-        </p:nvSpPr>
-        <p:spPr>
-          <a:xfrm>
-            <a:off x="5468112" y="1471168"/>
-            <a:ext cx="3218688" cy="397256"/>
+            <a:off x="585216" y="4197604"/>
+            <a:ext cx="7973568" cy="397256"/>
           </a:xfrm>
           <a:prstGeom prst="rect">
             <a:avLst/>
@@ -6416,7 +6657,7 @@
                 <a:ea typeface="Helvetica Neue" pitchFamily="34" charset="-122"/>
                 <a:cs typeface="Helvetica Neue" pitchFamily="34" charset="-120"/>
               </a:rPr>
-              <a:t>0.5 (0.236 to 0.767)</a:t>
+              <a:t>B2 Boltz-2, DD DiffDock-L. V valid, I invalid.</a:t>
             </a:r>
             <a:endParaRPr lang="en-US" sz="1600" dirty="0"/>
           </a:p>
@@ -6424,252 +6665,7 @@
       </p:sp>
       <p:sp>
         <p:nvSpPr>
-          <p:cNvPr id="15" name="Shape 12"/>
-          <p:cNvSpPr/>
-          <p:nvPr/>
-        </p:nvSpPr>
-        <p:spPr>
-          <a:xfrm>
-            <a:off x="5340096" y="1996440"/>
-            <a:ext cx="36576" cy="818896"/>
-          </a:xfrm>
-          <a:prstGeom prst="rect">
-            <a:avLst/>
-          </a:prstGeom>
-          <a:solidFill>
-            <a:srgbClr val="C9302C"/>
-          </a:solidFill>
-          <a:ln w="12700">
-            <a:solidFill>
-              <a:srgbClr val="C9302C"/>
-            </a:solidFill>
-            <a:prstDash val="solid"/>
-          </a:ln>
-        </p:spPr>
-      </p:sp>
-      <p:sp>
-        <p:nvSpPr>
-          <p:cNvPr id="16" name="support:sidebar:1:title"/>
-          <p:cNvSpPr txBox="1"/>
-          <p:nvPr/>
-        </p:nvSpPr>
-        <p:spPr>
-          <a:xfrm>
-            <a:off x="5468112" y="1996440"/>
-            <a:ext cx="3218688" cy="348488"/>
-          </a:xfrm>
-          <a:prstGeom prst="rect">
-            <a:avLst/>
-          </a:prstGeom>
-          <a:noFill/>
-          <a:ln/>
-        </p:spPr>
-        <p:txBody>
-          <a:bodyPr wrap="square" lIns="0" tIns="0" rIns="0" bIns="0" rtlCol="0" anchor="t"/>
-          <a:lstStyle/>
-          <a:p>
-            <a:pPr algn="l" indent="0" marL="0">
-              <a:buNone/>
-            </a:pPr>
-            <a:r>
-              <a:rPr lang="en-US" sz="1300" b="1" dirty="0">
-                <a:solidFill>
-                  <a:srgbClr val="C9302C"/>
-                </a:solidFill>
-                <a:latin typeface="Helvetica Neue" pitchFamily="34" charset="0"/>
-                <a:ea typeface="Helvetica Neue" pitchFamily="34" charset="-122"/>
-                <a:cs typeface="Helvetica Neue" pitchFamily="34" charset="-120"/>
-              </a:rPr>
-              <a:t>Fact file, pooled</a:t>
-            </a:r>
-            <a:endParaRPr lang="en-US" sz="1300" dirty="0"/>
-          </a:p>
-        </p:txBody>
-      </p:sp>
-      <p:sp>
-        <p:nvSpPr>
-          <p:cNvPr id="17" name="sidebar:1:body"/>
-          <p:cNvSpPr txBox="1"/>
-          <p:nvPr/>
-        </p:nvSpPr>
-        <p:spPr>
-          <a:xfrm>
-            <a:off x="5468112" y="2418080"/>
-            <a:ext cx="3218688" cy="397256"/>
-          </a:xfrm>
-          <a:prstGeom prst="rect">
-            <a:avLst/>
-          </a:prstGeom>
-          <a:noFill/>
-          <a:ln/>
-        </p:spPr>
-        <p:txBody>
-          <a:bodyPr wrap="square" lIns="0" tIns="0" rIns="0" bIns="0" rtlCol="0" anchor="t"/>
-          <a:lstStyle/>
-          <a:p>
-            <a:pPr algn="l" indent="0" marL="0">
-              <a:buNone/>
-            </a:pPr>
-            <a:r>
-              <a:rPr lang="en-US" sz="1600" dirty="0">
-                <a:solidFill>
-                  <a:srgbClr val="1B2838"/>
-                </a:solidFill>
-                <a:latin typeface="Helvetica Neue" pitchFamily="34" charset="0"/>
-                <a:ea typeface="Helvetica Neue" pitchFamily="34" charset="-122"/>
-                <a:cs typeface="Helvetica Neue" pitchFamily="34" charset="-120"/>
-              </a:rPr>
-              <a:t>0.533 (0.375 to 0.75)</a:t>
-            </a:r>
-            <a:endParaRPr lang="en-US" sz="1600" dirty="0"/>
-          </a:p>
-        </p:txBody>
-      </p:sp>
-      <p:sp>
-        <p:nvSpPr>
-          <p:cNvPr id="18" name="Shape 15"/>
-          <p:cNvSpPr/>
-          <p:nvPr/>
-        </p:nvSpPr>
-        <p:spPr>
-          <a:xfrm>
-            <a:off x="5340096" y="2943352"/>
-            <a:ext cx="36576" cy="818896"/>
-          </a:xfrm>
-          <a:prstGeom prst="rect">
-            <a:avLst/>
-          </a:prstGeom>
-          <a:solidFill>
-            <a:srgbClr val="0B2545"/>
-          </a:solidFill>
-          <a:ln w="12700">
-            <a:solidFill>
-              <a:srgbClr val="0B2545"/>
-            </a:solidFill>
-            <a:prstDash val="solid"/>
-          </a:ln>
-        </p:spPr>
-      </p:sp>
-      <p:sp>
-        <p:nvSpPr>
-          <p:cNvPr id="19" name="support:sidebar:2:title"/>
-          <p:cNvSpPr txBox="1"/>
-          <p:nvPr/>
-        </p:nvSpPr>
-        <p:spPr>
-          <a:xfrm>
-            <a:off x="5468112" y="2943352"/>
-            <a:ext cx="3218688" cy="348488"/>
-          </a:xfrm>
-          <a:prstGeom prst="rect">
-            <a:avLst/>
-          </a:prstGeom>
-          <a:noFill/>
-          <a:ln/>
-        </p:spPr>
-        <p:txBody>
-          <a:bodyPr wrap="square" lIns="0" tIns="0" rIns="0" bIns="0" rtlCol="0" anchor="t"/>
-          <a:lstStyle/>
-          <a:p>
-            <a:pPr algn="l" indent="0" marL="0">
-              <a:buNone/>
-            </a:pPr>
-            <a:r>
-              <a:rPr lang="en-US" sz="1300" b="1" dirty="0">
-                <a:solidFill>
-                  <a:srgbClr val="0B2545"/>
-                </a:solidFill>
-                <a:latin typeface="Helvetica Neue" pitchFamily="34" charset="0"/>
-                <a:ea typeface="Helvetica Neue" pitchFamily="34" charset="-122"/>
-                <a:cs typeface="Helvetica Neue" pitchFamily="34" charset="-120"/>
-              </a:rPr>
-              <a:t>McNemar exact p</a:t>
-            </a:r>
-            <a:endParaRPr lang="en-US" sz="1300" dirty="0"/>
-          </a:p>
-        </p:txBody>
-      </p:sp>
-      <p:sp>
-        <p:nvSpPr>
-          <p:cNvPr id="20" name="sidebar:2:body"/>
-          <p:cNvSpPr txBox="1"/>
-          <p:nvPr/>
-        </p:nvSpPr>
-        <p:spPr>
-          <a:xfrm>
-            <a:off x="5468112" y="3364992"/>
-            <a:ext cx="3218688" cy="397256"/>
-          </a:xfrm>
-          <a:prstGeom prst="rect">
-            <a:avLst/>
-          </a:prstGeom>
-          <a:noFill/>
-          <a:ln/>
-        </p:spPr>
-        <p:txBody>
-          <a:bodyPr wrap="square" lIns="0" tIns="0" rIns="0" bIns="0" rtlCol="0" anchor="t"/>
-          <a:lstStyle/>
-          <a:p>
-            <a:pPr algn="l" indent="0" marL="0">
-              <a:buNone/>
-            </a:pPr>
-            <a:r>
-              <a:rPr lang="en-US" sz="1600" dirty="0">
-                <a:solidFill>
-                  <a:srgbClr val="1B2838"/>
-                </a:solidFill>
-                <a:latin typeface="Helvetica Neue" pitchFamily="34" charset="0"/>
-                <a:ea typeface="Helvetica Neue" pitchFamily="34" charset="-122"/>
-                <a:cs typeface="Helvetica Neue" pitchFamily="34" charset="-120"/>
-              </a:rPr>
-              <a:t>0.6875; discordant 4 and 2</a:t>
-            </a:r>
-            <a:endParaRPr lang="en-US" sz="1600" dirty="0"/>
-          </a:p>
-        </p:txBody>
-      </p:sp>
-      <p:sp>
-        <p:nvSpPr>
-          <p:cNvPr id="21" name="metadata:sidebar:caption"/>
-          <p:cNvSpPr txBox="1"/>
-          <p:nvPr/>
-        </p:nvSpPr>
-        <p:spPr>
-          <a:xfrm>
-            <a:off x="457200" y="4384548"/>
-            <a:ext cx="8229600" cy="283464"/>
-          </a:xfrm>
-          <a:prstGeom prst="rect">
-            <a:avLst/>
-          </a:prstGeom>
-          <a:noFill/>
-          <a:ln/>
-        </p:spPr>
-        <p:txBody>
-          <a:bodyPr wrap="square" lIns="0" tIns="0" rIns="0" bIns="0" rtlCol="0" anchor="t"/>
-          <a:lstStyle/>
-          <a:p>
-            <a:pPr algn="l" indent="0" marL="0">
-              <a:buNone/>
-            </a:pPr>
-            <a:r>
-              <a:rPr lang="en-US" sz="900" i="1" dirty="0">
-                <a:solidFill>
-                  <a:srgbClr val="4B5563"/>
-                </a:solidFill>
-                <a:latin typeface="Helvetica Neue" pitchFamily="34" charset="0"/>
-                <a:ea typeface="Helvetica Neue" pitchFamily="34" charset="-122"/>
-                <a:cs typeface="Helvetica Neue" pitchFamily="34" charset="-120"/>
-              </a:rPr>
-              <a:t>Bootstrap over predictions; dashed line at 0.5.</a:t>
-            </a:r>
-            <a:endParaRPr lang="en-US" sz="900" dirty="0"/>
-          </a:p>
-        </p:txBody>
-      </p:sp>
-      <p:sp>
-        <p:nvSpPr>
-          <p:cNvPr id="22" name="Shape 19"/>
+          <p:cNvPr id="14" name="Shape 11"/>
           <p:cNvSpPr/>
           <p:nvPr/>
         </p:nvSpPr>
@@ -6694,7 +6690,7 @@
       </p:sp>
       <p:sp>
         <p:nvSpPr>
-          <p:cNvPr id="23" name="metadata:footer-sources"/>
+          <p:cNvPr id="15" name="metadata:footer-sources"/>
           <p:cNvSpPr txBox="1"/>
           <p:nvPr/>
         </p:nvSpPr>
@@ -6735,7 +6731,7 @@
       </p:sp>
       <p:sp>
         <p:nvSpPr>
-          <p:cNvPr id="24" name="metadata:footer-page-number"/>
+          <p:cNvPr id="16" name="metadata:footer-page-number"/>
           <p:cNvSpPr txBox="1"/>
           <p:nvPr/>
         </p:nvSpPr>
@@ -7005,7 +7001,7 @@
                 <a:ea typeface="Helvetica Neue" pitchFamily="34" charset="-122"/>
                 <a:cs typeface="Helvetica Neue" pitchFamily="34" charset="-120"/>
               </a:rPr>
-              <a:t>Decision per prediction</a:t>
+              <a:t>Aggregate over this run</a:t>
             </a:r>
             <a:endParaRPr lang="en-US" sz="2800" dirty="0"/>
           </a:p>
@@ -7061,48 +7057,9 @@
           </a:ln>
         </p:spPr>
       </p:sp>
-      <p:sp>
-        <p:nvSpPr>
-          <p:cNvPr id="11" name="support:scientific:A:title"/>
-          <p:cNvSpPr txBox="1"/>
-          <p:nvPr/>
-        </p:nvSpPr>
-        <p:spPr>
-          <a:xfrm>
-            <a:off x="530352" y="1113536"/>
-            <a:ext cx="8083296" cy="348488"/>
-          </a:xfrm>
-          <a:prstGeom prst="rect">
-            <a:avLst/>
-          </a:prstGeom>
-          <a:noFill/>
-          <a:ln/>
-        </p:spPr>
-        <p:txBody>
-          <a:bodyPr wrap="square" lIns="0" tIns="0" rIns="0" bIns="0" rtlCol="0" anchor="t"/>
-          <a:lstStyle/>
-          <a:p>
-            <a:pPr algn="l" indent="0" marL="0">
-              <a:buNone/>
-            </a:pPr>
-            <a:r>
-              <a:rPr lang="en-US" sz="1300" b="1" dirty="0">
-                <a:solidFill>
-                  <a:srgbClr val="1B2838"/>
-                </a:solidFill>
-                <a:latin typeface="Helvetica Neue" pitchFamily="34" charset="0"/>
-                <a:ea typeface="Helvetica Neue" pitchFamily="34" charset="-122"/>
-                <a:cs typeface="Helvetica Neue" pitchFamily="34" charset="-120"/>
-              </a:rPr>
-              <a:t>A. Ground truth and majority verdict per prediction</a:t>
-            </a:r>
-            <a:endParaRPr lang="en-US" sz="1300" dirty="0"/>
-          </a:p>
-        </p:txBody>
-      </p:sp>
       <p:pic>
         <p:nvPicPr>
-          <p:cNvPr id="12" name="scientific:A:image" descr="B2 Boltz-2, DD DiffDock-L. V valid, I invalid.">    </p:cNvPr>
+          <p:cNvPr id="11" name="sidebar:figure" descr="16 predictions; intervals are wide at this size. Invalid kept: score only 5 of 10, fact file 1 of 10. Dashed line at 0.5.">    </p:cNvPr>
           <p:cNvPicPr>
             <a:picLocks noChangeAspect="1"/>
           </p:cNvPicPr>
@@ -7116,8 +7073,8 @@
         </p:blipFill>
         <p:spPr>
           <a:xfrm>
-            <a:off x="512064" y="1542930"/>
-            <a:ext cx="8119872" cy="2308591"/>
+            <a:off x="457200" y="1232132"/>
+            <a:ext cx="4608576" cy="2805220"/>
           </a:xfrm>
           <a:prstGeom prst="rect">
             <a:avLst/>
@@ -7126,14 +7083,78 @@
       </p:pic>
       <p:sp>
         <p:nvSpPr>
-          <p:cNvPr id="13" name="scientific:complete-readout"/>
+          <p:cNvPr id="12" name="Shape 9"/>
+          <p:cNvSpPr/>
+          <p:nvPr/>
+        </p:nvSpPr>
+        <p:spPr>
+          <a:xfrm>
+            <a:off x="5340096" y="1049528"/>
+            <a:ext cx="36576" cy="818896"/>
+          </a:xfrm>
+          <a:prstGeom prst="rect">
+            <a:avLst/>
+          </a:prstGeom>
+          <a:solidFill>
+            <a:srgbClr val="0B2545"/>
+          </a:solidFill>
+          <a:ln w="12700">
+            <a:solidFill>
+              <a:srgbClr val="0B2545"/>
+            </a:solidFill>
+            <a:prstDash val="solid"/>
+          </a:ln>
+        </p:spPr>
+      </p:sp>
+      <p:sp>
+        <p:nvSpPr>
+          <p:cNvPr id="13" name="support:sidebar:0:title"/>
           <p:cNvSpPr txBox="1"/>
           <p:nvPr/>
         </p:nvSpPr>
         <p:spPr>
           <a:xfrm>
-            <a:off x="585216" y="4197604"/>
-            <a:ext cx="7973568" cy="397256"/>
+            <a:off x="5468112" y="1049528"/>
+            <a:ext cx="3218688" cy="348488"/>
+          </a:xfrm>
+          <a:prstGeom prst="rect">
+            <a:avLst/>
+          </a:prstGeom>
+          <a:noFill/>
+          <a:ln/>
+        </p:spPr>
+        <p:txBody>
+          <a:bodyPr wrap="square" lIns="0" tIns="0" rIns="0" bIns="0" rtlCol="0" anchor="t"/>
+          <a:lstStyle/>
+          <a:p>
+            <a:pPr algn="l" indent="0" marL="0">
+              <a:buNone/>
+            </a:pPr>
+            <a:r>
+              <a:rPr lang="en-US" sz="1300" b="1" dirty="0">
+                <a:solidFill>
+                  <a:srgbClr val="0B2545"/>
+                </a:solidFill>
+                <a:latin typeface="Helvetica Neue" pitchFamily="34" charset="0"/>
+                <a:ea typeface="Helvetica Neue" pitchFamily="34" charset="-122"/>
+                <a:cs typeface="Helvetica Neue" pitchFamily="34" charset="-120"/>
+              </a:rPr>
+              <a:t>Score only, pooled</a:t>
+            </a:r>
+            <a:endParaRPr lang="en-US" sz="1300" dirty="0"/>
+          </a:p>
+        </p:txBody>
+      </p:sp>
+      <p:sp>
+        <p:nvSpPr>
+          <p:cNvPr id="14" name="sidebar:0:body"/>
+          <p:cNvSpPr txBox="1"/>
+          <p:nvPr/>
+        </p:nvSpPr>
+        <p:spPr>
+          <a:xfrm>
+            <a:off x="5468112" y="1471168"/>
+            <a:ext cx="3218688" cy="397256"/>
           </a:xfrm>
           <a:prstGeom prst="rect">
             <a:avLst/>
@@ -7157,7 +7178,7 @@
                 <a:ea typeface="Helvetica Neue" pitchFamily="34" charset="-122"/>
                 <a:cs typeface="Helvetica Neue" pitchFamily="34" charset="-120"/>
               </a:rPr>
-              <a:t>B2 Boltz-2, DD DiffDock-L. V valid, I invalid.</a:t>
+              <a:t>0.5 (0.236 to 0.767)</a:t>
             </a:r>
             <a:endParaRPr lang="en-US" sz="1600" dirty="0"/>
           </a:p>
@@ -7165,7 +7186,252 @@
       </p:sp>
       <p:sp>
         <p:nvSpPr>
-          <p:cNvPr id="14" name="Shape 11"/>
+          <p:cNvPr id="15" name="Shape 12"/>
+          <p:cNvSpPr/>
+          <p:nvPr/>
+        </p:nvSpPr>
+        <p:spPr>
+          <a:xfrm>
+            <a:off x="5340096" y="1996440"/>
+            <a:ext cx="36576" cy="818896"/>
+          </a:xfrm>
+          <a:prstGeom prst="rect">
+            <a:avLst/>
+          </a:prstGeom>
+          <a:solidFill>
+            <a:srgbClr val="C9302C"/>
+          </a:solidFill>
+          <a:ln w="12700">
+            <a:solidFill>
+              <a:srgbClr val="C9302C"/>
+            </a:solidFill>
+            <a:prstDash val="solid"/>
+          </a:ln>
+        </p:spPr>
+      </p:sp>
+      <p:sp>
+        <p:nvSpPr>
+          <p:cNvPr id="16" name="support:sidebar:1:title"/>
+          <p:cNvSpPr txBox="1"/>
+          <p:nvPr/>
+        </p:nvSpPr>
+        <p:spPr>
+          <a:xfrm>
+            <a:off x="5468112" y="1996440"/>
+            <a:ext cx="3218688" cy="348488"/>
+          </a:xfrm>
+          <a:prstGeom prst="rect">
+            <a:avLst/>
+          </a:prstGeom>
+          <a:noFill/>
+          <a:ln/>
+        </p:spPr>
+        <p:txBody>
+          <a:bodyPr wrap="square" lIns="0" tIns="0" rIns="0" bIns="0" rtlCol="0" anchor="t"/>
+          <a:lstStyle/>
+          <a:p>
+            <a:pPr algn="l" indent="0" marL="0">
+              <a:buNone/>
+            </a:pPr>
+            <a:r>
+              <a:rPr lang="en-US" sz="1300" b="1" dirty="0">
+                <a:solidFill>
+                  <a:srgbClr val="C9302C"/>
+                </a:solidFill>
+                <a:latin typeface="Helvetica Neue" pitchFamily="34" charset="0"/>
+                <a:ea typeface="Helvetica Neue" pitchFamily="34" charset="-122"/>
+                <a:cs typeface="Helvetica Neue" pitchFamily="34" charset="-120"/>
+              </a:rPr>
+              <a:t>Fact file, pooled</a:t>
+            </a:r>
+            <a:endParaRPr lang="en-US" sz="1300" dirty="0"/>
+          </a:p>
+        </p:txBody>
+      </p:sp>
+      <p:sp>
+        <p:nvSpPr>
+          <p:cNvPr id="17" name="sidebar:1:body"/>
+          <p:cNvSpPr txBox="1"/>
+          <p:nvPr/>
+        </p:nvSpPr>
+        <p:spPr>
+          <a:xfrm>
+            <a:off x="5468112" y="2418080"/>
+            <a:ext cx="3218688" cy="397256"/>
+          </a:xfrm>
+          <a:prstGeom prst="rect">
+            <a:avLst/>
+          </a:prstGeom>
+          <a:noFill/>
+          <a:ln/>
+        </p:spPr>
+        <p:txBody>
+          <a:bodyPr wrap="square" lIns="0" tIns="0" rIns="0" bIns="0" rtlCol="0" anchor="t"/>
+          <a:lstStyle/>
+          <a:p>
+            <a:pPr algn="l" indent="0" marL="0">
+              <a:buNone/>
+            </a:pPr>
+            <a:r>
+              <a:rPr lang="en-US" sz="1600" dirty="0">
+                <a:solidFill>
+                  <a:srgbClr val="1B2838"/>
+                </a:solidFill>
+                <a:latin typeface="Helvetica Neue" pitchFamily="34" charset="0"/>
+                <a:ea typeface="Helvetica Neue" pitchFamily="34" charset="-122"/>
+                <a:cs typeface="Helvetica Neue" pitchFamily="34" charset="-120"/>
+              </a:rPr>
+              <a:t>0.533 (0.375 to 0.75)</a:t>
+            </a:r>
+            <a:endParaRPr lang="en-US" sz="1600" dirty="0"/>
+          </a:p>
+        </p:txBody>
+      </p:sp>
+      <p:sp>
+        <p:nvSpPr>
+          <p:cNvPr id="18" name="Shape 15"/>
+          <p:cNvSpPr/>
+          <p:nvPr/>
+        </p:nvSpPr>
+        <p:spPr>
+          <a:xfrm>
+            <a:off x="5340096" y="2943352"/>
+            <a:ext cx="36576" cy="818896"/>
+          </a:xfrm>
+          <a:prstGeom prst="rect">
+            <a:avLst/>
+          </a:prstGeom>
+          <a:solidFill>
+            <a:srgbClr val="0B2545"/>
+          </a:solidFill>
+          <a:ln w="12700">
+            <a:solidFill>
+              <a:srgbClr val="0B2545"/>
+            </a:solidFill>
+            <a:prstDash val="solid"/>
+          </a:ln>
+        </p:spPr>
+      </p:sp>
+      <p:sp>
+        <p:nvSpPr>
+          <p:cNvPr id="19" name="support:sidebar:2:title"/>
+          <p:cNvSpPr txBox="1"/>
+          <p:nvPr/>
+        </p:nvSpPr>
+        <p:spPr>
+          <a:xfrm>
+            <a:off x="5468112" y="2943352"/>
+            <a:ext cx="3218688" cy="348488"/>
+          </a:xfrm>
+          <a:prstGeom prst="rect">
+            <a:avLst/>
+          </a:prstGeom>
+          <a:noFill/>
+          <a:ln/>
+        </p:spPr>
+        <p:txBody>
+          <a:bodyPr wrap="square" lIns="0" tIns="0" rIns="0" bIns="0" rtlCol="0" anchor="t"/>
+          <a:lstStyle/>
+          <a:p>
+            <a:pPr algn="l" indent="0" marL="0">
+              <a:buNone/>
+            </a:pPr>
+            <a:r>
+              <a:rPr lang="en-US" sz="1300" b="1" dirty="0">
+                <a:solidFill>
+                  <a:srgbClr val="0B2545"/>
+                </a:solidFill>
+                <a:latin typeface="Helvetica Neue" pitchFamily="34" charset="0"/>
+                <a:ea typeface="Helvetica Neue" pitchFamily="34" charset="-122"/>
+                <a:cs typeface="Helvetica Neue" pitchFamily="34" charset="-120"/>
+              </a:rPr>
+              <a:t>McNemar exact p</a:t>
+            </a:r>
+            <a:endParaRPr lang="en-US" sz="1300" dirty="0"/>
+          </a:p>
+        </p:txBody>
+      </p:sp>
+      <p:sp>
+        <p:nvSpPr>
+          <p:cNvPr id="20" name="sidebar:2:body"/>
+          <p:cNvSpPr txBox="1"/>
+          <p:nvPr/>
+        </p:nvSpPr>
+        <p:spPr>
+          <a:xfrm>
+            <a:off x="5468112" y="3364992"/>
+            <a:ext cx="3218688" cy="397256"/>
+          </a:xfrm>
+          <a:prstGeom prst="rect">
+            <a:avLst/>
+          </a:prstGeom>
+          <a:noFill/>
+          <a:ln/>
+        </p:spPr>
+        <p:txBody>
+          <a:bodyPr wrap="square" lIns="0" tIns="0" rIns="0" bIns="0" rtlCol="0" anchor="t"/>
+          <a:lstStyle/>
+          <a:p>
+            <a:pPr algn="l" indent="0" marL="0">
+              <a:buNone/>
+            </a:pPr>
+            <a:r>
+              <a:rPr lang="en-US" sz="1600" dirty="0">
+                <a:solidFill>
+                  <a:srgbClr val="1B2838"/>
+                </a:solidFill>
+                <a:latin typeface="Helvetica Neue" pitchFamily="34" charset="0"/>
+                <a:ea typeface="Helvetica Neue" pitchFamily="34" charset="-122"/>
+                <a:cs typeface="Helvetica Neue" pitchFamily="34" charset="-120"/>
+              </a:rPr>
+              <a:t>0.6875; discordant 4 and 2</a:t>
+            </a:r>
+            <a:endParaRPr lang="en-US" sz="1600" dirty="0"/>
+          </a:p>
+        </p:txBody>
+      </p:sp>
+      <p:sp>
+        <p:nvSpPr>
+          <p:cNvPr id="21" name="metadata:sidebar:caption"/>
+          <p:cNvSpPr txBox="1"/>
+          <p:nvPr/>
+        </p:nvSpPr>
+        <p:spPr>
+          <a:xfrm>
+            <a:off x="457200" y="4384548"/>
+            <a:ext cx="8229600" cy="283464"/>
+          </a:xfrm>
+          <a:prstGeom prst="rect">
+            <a:avLst/>
+          </a:prstGeom>
+          <a:noFill/>
+          <a:ln/>
+        </p:spPr>
+        <p:txBody>
+          <a:bodyPr wrap="square" lIns="0" tIns="0" rIns="0" bIns="0" rtlCol="0" anchor="t"/>
+          <a:lstStyle/>
+          <a:p>
+            <a:pPr algn="l" indent="0" marL="0">
+              <a:buNone/>
+            </a:pPr>
+            <a:r>
+              <a:rPr lang="en-US" sz="900" i="1" dirty="0">
+                <a:solidFill>
+                  <a:srgbClr val="4B5563"/>
+                </a:solidFill>
+                <a:latin typeface="Helvetica Neue" pitchFamily="34" charset="0"/>
+                <a:ea typeface="Helvetica Neue" pitchFamily="34" charset="-122"/>
+                <a:cs typeface="Helvetica Neue" pitchFamily="34" charset="-120"/>
+              </a:rPr>
+              <a:t>16 predictions; intervals are wide at this size. Invalid kept: score only 5 of 10, fact file 1 of 10. Dashed line at 0.5.</a:t>
+            </a:r>
+            <a:endParaRPr lang="en-US" sz="900" dirty="0"/>
+          </a:p>
+        </p:txBody>
+      </p:sp>
+      <p:sp>
+        <p:nvSpPr>
+          <p:cNvPr id="22" name="Shape 19"/>
           <p:cNvSpPr/>
           <p:nvPr/>
         </p:nvSpPr>
@@ -7190,7 +7456,7 @@
       </p:sp>
       <p:sp>
         <p:nvSpPr>
-          <p:cNvPr id="15" name="metadata:footer-sources"/>
+          <p:cNvPr id="23" name="metadata:footer-sources"/>
           <p:cNvSpPr txBox="1"/>
           <p:nvPr/>
         </p:nvSpPr>
@@ -7231,7 +7497,7 @@
       </p:sp>
       <p:sp>
         <p:nvSpPr>
-          <p:cNvPr id="16" name="metadata:footer-page-number"/>
+          <p:cNvPr id="24" name="metadata:footer-page-number"/>
           <p:cNvSpPr txBox="1"/>
           <p:nvPr/>
         </p:nvSpPr>

</xml_diff>